<commit_message>
Fix README to reflect Render deployment (not Railway), add Week 4 report
README incorrectly referenced Railway throughout, but the app was actually
deployed to Render using Docker. Updated tech stack, file list, and
deployment steps to match. Also added the Week 4 weekly training report
and its generator script, plus the latest deployment screenshot.
</commit_message>
<xml_diff>
--- a/Task-Management-Presentation.pptx
+++ b/Task-Management-Presentation.pptx
@@ -4,6 +4,9 @@
   <p:sldMasterIdLst>
     <p:sldMasterId id="2147483648" r:id="rId1"/>
   </p:sldMasterIdLst>
+  <p:notesMasterIdLst>
+    <p:notesMasterId r:id="rId13"/>
+  </p:notesMasterIdLst>
   <p:sldIdLst>
     <p:sldId id="256" r:id="rId2"/>
     <p:sldId id="257" r:id="rId3"/>
@@ -17,10 +20,7 @@
     <p:sldId id="265" r:id="rId11"/>
     <p:sldId id="266" r:id="rId12"/>
   </p:sldIdLst>
-  <p:notesMasterIdLst>
-    <p:notesMasterId r:id="rId13"/>
-  </p:notesMasterIdLst>
-  <p:sldSz cx="9144000" cy="5143500"/>
+  <p:sldSz cx="9144000" cy="5143500" type="screen16x9"/>
   <p:notesSz cx="5143500" cy="9144000"/>
   <p:defaultTextStyle>
     <a:lvl1pPr marL="0" algn="l" defTabSz="914400" rtl="0" eaLnBrk="1" latinLnBrk="0" hangingPunct="1">
@@ -114,6 +114,11 @@
       </a:defRPr>
     </a:lvl9pPr>
   </p:defaultTextStyle>
+  <p:extLst>
+    <p:ext uri="{EFAFB233-063F-42B5-8137-9DF3F51BA10A}">
+      <p15:sldGuideLst xmlns:p15="http://schemas.microsoft.com/office/powerpoint/2012/main"/>
+    </p:ext>
+  </p:extLst>
 </p:presentation>
 </file>
 
@@ -139,234 +144,10 @@
           <a:chExt cx="0" cy="0"/>
         </a:xfrm>
       </p:grpSpPr>
-      <p:sp>
-        <p:nvSpPr>
-          <p:cNvPr id="2" name="Header Placeholder 1"/>
-          <p:cNvSpPr>
-            <a:spLocks noGrp="1"/>
-          </p:cNvSpPr>
-          <p:nvPr>
-            <p:ph type="hdr" sz="quarter"/>
-          </p:nvPr>
-        </p:nvSpPr>
-        <p:spPr>
-          <a:xfrm>
-            <a:off x="0" y="0"/>
-            <a:ext cx="2971800" cy="458788"/>
-          </a:xfrm>
-          <a:prstGeom prst="rect">
-            <a:avLst/>
-          </a:prstGeom>
-        </p:spPr>
-        <p:txBody>
-          <a:bodyPr vert="horz" lIns="91440" tIns="45720" rIns="91440" bIns="45720" rtlCol="0"/>
-          <a:lstStyle>
-            <a:lvl1pPr algn="l">
-              <a:defRPr sz="1200"/>
-            </a:lvl1pPr>
-          </a:lstStyle>
-          <a:p>
-            <a:endParaRPr lang="en-US"/>
-          </a:p>
-        </p:txBody>
-      </p:sp>
-      <p:sp>
-        <p:nvSpPr>
-          <p:cNvPr id="3" name="Date Placeholder 2"/>
-          <p:cNvSpPr>
-            <a:spLocks noGrp="1"/>
-          </p:cNvSpPr>
-          <p:nvPr>
-            <p:ph type="dt" idx="1"/>
-          </p:nvPr>
-        </p:nvSpPr>
-        <p:spPr>
-          <a:xfrm>
-            <a:off x="3884613" y="0"/>
-            <a:ext cx="2971800" cy="458788"/>
-          </a:xfrm>
-          <a:prstGeom prst="rect">
-            <a:avLst/>
-          </a:prstGeom>
-        </p:spPr>
-        <p:txBody>
-          <a:bodyPr vert="horz" lIns="91440" tIns="45720" rIns="91440" bIns="45720" rtlCol="0"/>
-          <a:lstStyle>
-            <a:lvl1pPr algn="r">
-              <a:defRPr sz="1200"/>
-            </a:lvl1pPr>
-          </a:lstStyle>
-          <a:p>
-            <a:fld id="{5282F153-3F37-0F45-9E97-73ACFA13230C}" type="datetimeFigureOut">
-              <a:rPr lang="en-US"/>
-              <a:t>7/23/19</a:t>
-            </a:fld>
-            <a:endParaRPr lang="en-US"/>
-          </a:p>
-        </p:txBody>
-      </p:sp>
-      <p:sp>
-        <p:nvSpPr>
-          <p:cNvPr id="4" name="Slide Image Placeholder 3"/>
-          <p:cNvSpPr>
-            <a:spLocks noGrp="1" noRot="1" noChangeAspect="1"/>
-          </p:cNvSpPr>
-          <p:nvPr>
-            <p:ph type="sldImg" idx="2"/>
-          </p:nvPr>
-        </p:nvSpPr>
-        <p:spPr>
-          <a:xfrm>
-            <a:off x="685800" y="1143000"/>
-            <a:ext cx="5486400" cy="3086100"/>
-          </a:xfrm>
-          <a:prstGeom prst="rect">
-            <a:avLst/>
-          </a:prstGeom>
-          <a:noFill/>
-          <a:ln w="12700">
-            <a:solidFill>
-              <a:prstClr val="black"/>
-            </a:solidFill>
-          </a:ln>
-        </p:spPr>
-        <p:txBody>
-          <a:bodyPr vert="horz" lIns="91440" tIns="45720" rIns="91440" bIns="45720" rtlCol="0" anchor="ctr"/>
-          <a:lstStyle/>
-          <a:p>
-            <a:endParaRPr lang="en-US"/>
-          </a:p>
-        </p:txBody>
-      </p:sp>
-      <p:sp>
-        <p:nvSpPr>
-          <p:cNvPr id="5" name="Notes Placeholder 4"/>
-          <p:cNvSpPr>
-            <a:spLocks noGrp="1"/>
-          </p:cNvSpPr>
-          <p:nvPr>
-            <p:ph type="body" sz="quarter" idx="3"/>
-          </p:nvPr>
-        </p:nvSpPr>
-        <p:spPr>
-          <a:xfrm>
-            <a:off x="685800" y="4400550"/>
-            <a:ext cx="5486400" cy="3600450"/>
-          </a:xfrm>
-          <a:prstGeom prst="rect">
-            <a:avLst/>
-          </a:prstGeom>
-        </p:spPr>
-        <p:txBody>
-          <a:bodyPr vert="horz" lIns="91440" tIns="45720" rIns="91440" bIns="45720" rtlCol="0"/>
-          <a:lstStyle/>
-          <a:p>
-            <a:pPr lvl="0"/>
-            <a:r>
-              <a:rPr lang="en-US"/>
-              <a:t>Click to edit Master text styles</a:t>
-            </a:r>
-          </a:p>
-          <a:p>
-            <a:pPr lvl="1"/>
-            <a:r>
-              <a:rPr lang="en-US"/>
-              <a:t>Second level</a:t>
-            </a:r>
-          </a:p>
-          <a:p>
-            <a:pPr lvl="2"/>
-            <a:r>
-              <a:rPr lang="en-US"/>
-              <a:t>Third level</a:t>
-            </a:r>
-          </a:p>
-          <a:p>
-            <a:pPr lvl="3"/>
-            <a:r>
-              <a:rPr lang="en-US"/>
-              <a:t>Fourth level</a:t>
-            </a:r>
-          </a:p>
-          <a:p>
-            <a:pPr lvl="4"/>
-            <a:r>
-              <a:rPr lang="en-US"/>
-              <a:t>Fifth level</a:t>
-            </a:r>
-          </a:p>
-        </p:txBody>
-      </p:sp>
-      <p:sp>
-        <p:nvSpPr>
-          <p:cNvPr id="6" name="Footer Placeholder 5"/>
-          <p:cNvSpPr>
-            <a:spLocks noGrp="1"/>
-          </p:cNvSpPr>
-          <p:nvPr>
-            <p:ph type="ftr" sz="quarter" idx="4"/>
-          </p:nvPr>
-        </p:nvSpPr>
-        <p:spPr>
-          <a:xfrm>
-            <a:off x="0" y="8685213"/>
-            <a:ext cx="2971800" cy="458787"/>
-          </a:xfrm>
-          <a:prstGeom prst="rect">
-            <a:avLst/>
-          </a:prstGeom>
-        </p:spPr>
-        <p:txBody>
-          <a:bodyPr vert="horz" lIns="91440" tIns="45720" rIns="91440" bIns="45720" rtlCol="0" anchor="b"/>
-          <a:lstStyle>
-            <a:lvl1pPr algn="l">
-              <a:defRPr sz="1200"/>
-            </a:lvl1pPr>
-          </a:lstStyle>
-          <a:p>
-            <a:endParaRPr lang="en-US"/>
-          </a:p>
-        </p:txBody>
-      </p:sp>
-      <p:sp>
-        <p:nvSpPr>
-          <p:cNvPr id="7" name="Slide Number Placeholder 6"/>
-          <p:cNvSpPr>
-            <a:spLocks noGrp="1"/>
-          </p:cNvSpPr>
-          <p:nvPr>
-            <p:ph type="sldNum" sz="quarter" idx="5"/>
-          </p:nvPr>
-        </p:nvSpPr>
-        <p:spPr>
-          <a:xfrm>
-            <a:off x="3884613" y="8685213"/>
-            <a:ext cx="2971800" cy="458787"/>
-          </a:xfrm>
-          <a:prstGeom prst="rect">
-            <a:avLst/>
-          </a:prstGeom>
-        </p:spPr>
-        <p:txBody>
-          <a:bodyPr vert="horz" lIns="91440" tIns="45720" rIns="91440" bIns="45720" rtlCol="0" anchor="b"/>
-          <a:lstStyle>
-            <a:lvl1pPr algn="r">
-              <a:defRPr sz="1200"/>
-            </a:lvl1pPr>
-          </a:lstStyle>
-          <a:p>
-            <a:fld id="{CE5E9CC1-C706-0F49-92D6-E571CC5EEA8F}" type="slidenum">
-              <a:rPr lang="en-US"/>
-              <a:t>‹#›</a:t>
-            </a:fld>
-            <a:endParaRPr lang="en-US"/>
-          </a:p>
-        </p:txBody>
-      </p:sp>
     </p:spTree>
     <p:extLst>
       <p:ext uri="{BB962C8B-B14F-4D97-AF65-F5344CB8AC3E}">
-        <p14:creationId xmlns:p14="http://schemas.microsoft.com/office/powerpoint/2010/main" val="1024086991"/>
+        <p14:creationId xmlns:p14="http://schemas.microsoft.com/office/powerpoint/2010/main" val="3432370671"/>
       </p:ext>
     </p:extLst>
   </p:cSld>
@@ -514,7 +295,6 @@
               <a:rPr lang="en-US" dirty="0"/>
               <a:t>Introduce yourself. Say: Today I'll walk you through my Week 3 and Week 4 project — a full-stack Task Management System built with Spring Boot, JWT security, Role-Based Access Control, and deployed live on Render.</a:t>
             </a:r>
-            <a:endParaRPr lang="en-US" dirty="0"/>
           </a:p>
         </p:txBody>
       </p:sp>
@@ -602,7 +382,6 @@
               <a:rPr lang="en-US" dirty="0"/>
               <a:t>This slide maps directly to the evaluation criteria from HR. Technical implementation is covered by RBAC, notifications, and deployment. Code quality shows in the architecture and validation. Documentation is the Swagger UI and README.</a:t>
             </a:r>
-            <a:endParaRPr lang="en-US" dirty="0"/>
           </a:p>
         </p:txBody>
       </p:sp>
@@ -690,7 +469,6 @@
               <a:rPr lang="en-US" dirty="0"/>
               <a:t>End with a live demo. Open the browser, go to the live URL, register a new user, create a task with a past due date to show overdue badge, then log in as admin to show the admin panel. Open Swagger UI as the final wow factor.</a:t>
             </a:r>
-            <a:endParaRPr lang="en-US" dirty="0"/>
           </a:p>
         </p:txBody>
       </p:sp>
@@ -778,7 +556,6 @@
               <a:rPr lang="en-US" dirty="0"/>
               <a:t>Quick agenda overview. Tell them: We'll start with the tech stack, then walk through what I built in Week 3, what I added in Week 4, and end with a live demo.</a:t>
             </a:r>
-            <a:endParaRPr lang="en-US" dirty="0"/>
           </a:p>
         </p:txBody>
       </p:sp>
@@ -866,7 +643,6 @@
               <a:rPr lang="en-US" dirty="0"/>
               <a:t>Walk through the tech stack. Highlight: Spring Boot for the backend API, Spring Security + JWT for authentication, H2 for local dev and MySQL for production, and Swagger for API documentation.</a:t>
             </a:r>
-            <a:endParaRPr lang="en-US" dirty="0"/>
           </a:p>
         </p:txBody>
       </p:sp>
@@ -954,7 +730,6 @@
               <a:rPr lang="en-US" dirty="0"/>
               <a:t>Week 3 was about building the foundation. JWT auth, full CRUD for tasks, and a clean frontend UI. The app already had role enums but they weren't enforced yet — that came in Week 4.</a:t>
             </a:r>
-            <a:endParaRPr lang="en-US" dirty="0"/>
           </a:p>
         </p:txBody>
       </p:sp>
@@ -1042,7 +817,6 @@
               <a:rPr lang="en-US" dirty="0"/>
               <a:t>Week 4 added the advanced features. The biggest ones are RBAC — where roles are now actually enforced, not just stored — and the Admin Panel where you can manage users from the UI. Also added overdue detection, email notifications, Swagger docs, and deployed to Render.</a:t>
             </a:r>
-            <a:endParaRPr lang="en-US" dirty="0"/>
           </a:p>
         </p:txBody>
       </p:sp>
@@ -1130,7 +904,6 @@
               <a:rPr lang="en-US" dirty="0"/>
               <a:t>This is the access control table. Key point: regular users can only see their own tasks. Only admins can view all tasks, assign tasks, and manage users. This is enforced with @PreAuthorize annotations on every endpoint.</a:t>
             </a:r>
-            <a:endParaRPr lang="en-US" dirty="0"/>
           </a:p>
         </p:txBody>
       </p:sp>
@@ -1218,7 +991,6 @@
               <a:rPr lang="en-US" dirty="0"/>
               <a:t>The app is deployed live on Render using Docker. Every push to GitHub triggers an automatic redeploy. The free tier is good enough for demo purposes. Show the live URL to evaluators.</a:t>
             </a:r>
-            <a:endParaRPr lang="en-US" dirty="0"/>
           </a:p>
         </p:txBody>
       </p:sp>
@@ -1306,7 +1078,6 @@
               <a:rPr lang="en-US" dirty="0"/>
               <a:t>Three groups of endpoints. Auth is public. Task endpoints require a JWT token. Admin endpoints require ROLE_ADMIN. The overdue endpoint is new in Week 4.</a:t>
             </a:r>
-            <a:endParaRPr lang="en-US" dirty="0"/>
           </a:p>
         </p:txBody>
       </p:sp>
@@ -1394,7 +1165,6 @@
               <a:rPr lang="en-US" dirty="0"/>
               <a:t>Standard Spring Boot layered architecture. Each layer has a clear responsibility. Files marked W4 are new in Week 4. The security layer handles JWT filtering for every request.</a:t>
             </a:r>
-            <a:endParaRPr lang="en-US" dirty="0"/>
           </a:p>
         </p:txBody>
       </p:sp>
@@ -1467,6 +1237,11 @@
 <file path=ppt/slideMasters/slideMaster1.xml><?xml version="1.0" encoding="utf-8"?>
 <p:sldMaster xmlns:a="http://schemas.openxmlformats.org/drawingml/2006/main" xmlns:r="http://schemas.openxmlformats.org/officeDocument/2006/relationships" xmlns:p="http://schemas.openxmlformats.org/presentationml/2006/main">
   <p:cSld>
+    <p:bg>
+      <p:bgRef idx="1001">
+        <a:schemeClr val="bg1"/>
+      </p:bgRef>
+    </p:bg>
     <p:spTree>
       <p:nvGrpSpPr>
         <p:cNvPr id="1" name=""/>
@@ -1749,6 +1524,7 @@
         <a:solidFill>
           <a:srgbClr val="0A1628"/>
         </a:solidFill>
+        <a:effectLst/>
       </p:bgPr>
     </p:bg>
     <p:spTree>
@@ -1844,11 +1620,11 @@
           <a:bodyPr wrap="square" rtlCol="0" anchor="ctr"/>
           <a:lstStyle/>
           <a:p>
-            <a:pPr algn="l" indent="0" marL="0">
-              <a:buNone/>
-            </a:pPr>
-            <a:r>
-              <a:rPr lang="en-US" sz="1300" b="1" spc="400" kern="0" dirty="0">
+            <a:pPr marL="0" indent="0" algn="l">
+              <a:buNone/>
+            </a:pPr>
+            <a:r>
+              <a:rPr lang="en-US" sz="1300" b="1" kern="0" spc="400" dirty="0">
                 <a:solidFill>
                   <a:srgbClr val="0EA5E9"/>
                 </a:solidFill>
@@ -1880,7 +1656,7 @@
           <a:bodyPr wrap="square" rtlCol="0" anchor="ctr"/>
           <a:lstStyle/>
           <a:p>
-            <a:pPr algn="l" indent="0" marL="0">
+            <a:pPr marL="0" indent="0" algn="l">
               <a:buNone/>
             </a:pPr>
             <a:r>
@@ -1916,7 +1692,7 @@
           <a:bodyPr wrap="square" rtlCol="0" anchor="ctr"/>
           <a:lstStyle/>
           <a:p>
-            <a:pPr algn="l" indent="0" marL="0">
+            <a:pPr marL="0" indent="0" algn="l">
               <a:buNone/>
             </a:pPr>
             <a:r>
@@ -1977,7 +1753,7 @@
           <a:bodyPr wrap="square" rtlCol="0" anchor="ctr"/>
           <a:lstStyle/>
           <a:p>
-            <a:pPr algn="l" indent="0" marL="0">
+            <a:pPr marL="0" indent="0" algn="l">
               <a:buNone/>
             </a:pPr>
             <a:r>
@@ -1988,10 +1764,23 @@
               </a:rPr>
               <a:t>Jeevan Kumar Gujja</a:t>
             </a:r>
+          </a:p>
+          <a:p>
+            <a:pPr marL="0" indent="0" algn="l">
+              <a:buNone/>
+            </a:pPr>
+            <a:r>
+              <a:rPr lang="en-US" sz="1400" b="1" dirty="0">
+                <a:solidFill>
+                  <a:srgbClr val="94A3B8"/>
+                </a:solidFill>
+              </a:rPr>
+              <a:t>jeevan@hashclicksolutions.com</a:t>
+            </a:r>
             <a:endParaRPr lang="en-US" sz="1400" dirty="0"/>
           </a:p>
           <a:p>
-            <a:pPr algn="l" indent="0" marL="0">
+            <a:pPr marL="0" indent="0" algn="l">
               <a:buNone/>
             </a:pPr>
             <a:r>
@@ -2000,7 +1789,7 @@
                   <a:srgbClr val="94A3B8"/>
                 </a:solidFill>
               </a:rPr>
-              <a:t>Java Developer Trainee  |  Hashclick Solutions LLC</a:t>
+              <a:t>Java Developer   |  Hashclick Solutions LLC</a:t>
             </a:r>
             <a:endParaRPr lang="en-US" sz="1400" dirty="0"/>
           </a:p>
@@ -2022,6 +1811,7 @@
         <a:solidFill>
           <a:srgbClr val="FFFFFF"/>
         </a:solidFill>
+        <a:effectLst/>
       </p:bgPr>
     </p:bg>
     <p:spTree>
@@ -2059,7 +1849,7 @@
           <a:bodyPr wrap="square" rtlCol="0" anchor="ctr"/>
           <a:lstStyle/>
           <a:p>
-            <a:pPr indent="0" marL="0">
+            <a:pPr marL="0" indent="0">
               <a:buNone/>
             </a:pPr>
             <a:r>
@@ -2100,7 +1890,7 @@
             <a:prstDash val="solid"/>
           </a:ln>
           <a:effectLst>
-            <a:outerShdw sx="100000" sy="100000" kx="0" ky="0" algn="bl" rotWithShape="0" blurRad="101600" dist="38100" dir="2700000">
+            <a:outerShdw blurRad="101600" dist="38100" dir="2700000" algn="bl" rotWithShape="0">
               <a:srgbClr val="000000">
                 <a:alpha val="12000"/>
               </a:srgbClr>
@@ -2181,7 +1971,7 @@
           <a:bodyPr wrap="square" lIns="0" tIns="0" rIns="0" bIns="0" rtlCol="0" anchor="ctr"/>
           <a:lstStyle/>
           <a:p>
-            <a:pPr algn="ctr" indent="0" marL="0">
+            <a:pPr marL="0" indent="0" algn="ctr">
               <a:buNone/>
             </a:pPr>
             <a:r>
@@ -2242,7 +2032,7 @@
           <a:bodyPr wrap="square" lIns="0" tIns="0" rIns="0" bIns="0" rtlCol="0" anchor="ctr"/>
           <a:lstStyle/>
           <a:p>
-            <a:pPr indent="0" marL="0">
+            <a:pPr marL="0" indent="0">
               <a:buNone/>
             </a:pPr>
             <a:r>
@@ -2303,7 +2093,7 @@
           <a:bodyPr wrap="square" lIns="0" tIns="0" rIns="0" bIns="0" rtlCol="0" anchor="ctr"/>
           <a:lstStyle/>
           <a:p>
-            <a:pPr indent="0" marL="0">
+            <a:pPr marL="0" indent="0">
               <a:buNone/>
             </a:pPr>
             <a:r>
@@ -2364,7 +2154,7 @@
           <a:bodyPr wrap="square" lIns="0" tIns="0" rIns="0" bIns="0" rtlCol="0" anchor="ctr"/>
           <a:lstStyle/>
           <a:p>
-            <a:pPr indent="0" marL="0">
+            <a:pPr marL="0" indent="0">
               <a:buNone/>
             </a:pPr>
             <a:r>
@@ -2425,7 +2215,7 @@
           <a:bodyPr wrap="square" lIns="0" tIns="0" rIns="0" bIns="0" rtlCol="0" anchor="ctr"/>
           <a:lstStyle/>
           <a:p>
-            <a:pPr indent="0" marL="0">
+            <a:pPr marL="0" indent="0">
               <a:buNone/>
             </a:pPr>
             <a:r>
@@ -2486,7 +2276,7 @@
           <a:bodyPr wrap="square" lIns="0" tIns="0" rIns="0" bIns="0" rtlCol="0" anchor="ctr"/>
           <a:lstStyle/>
           <a:p>
-            <a:pPr indent="0" marL="0">
+            <a:pPr marL="0" indent="0">
               <a:buNone/>
             </a:pPr>
             <a:r>
@@ -2527,7 +2317,7 @@
             <a:prstDash val="solid"/>
           </a:ln>
           <a:effectLst>
-            <a:outerShdw sx="100000" sy="100000" kx="0" ky="0" algn="bl" rotWithShape="0" blurRad="101600" dist="38100" dir="2700000">
+            <a:outerShdw blurRad="101600" dist="38100" dir="2700000" algn="bl" rotWithShape="0">
               <a:srgbClr val="000000">
                 <a:alpha val="12000"/>
               </a:srgbClr>
@@ -2608,7 +2398,7 @@
           <a:bodyPr wrap="square" lIns="0" tIns="0" rIns="0" bIns="0" rtlCol="0" anchor="ctr"/>
           <a:lstStyle/>
           <a:p>
-            <a:pPr algn="ctr" indent="0" marL="0">
+            <a:pPr marL="0" indent="0" algn="ctr">
               <a:buNone/>
             </a:pPr>
             <a:r>
@@ -2669,7 +2459,7 @@
           <a:bodyPr wrap="square" lIns="0" tIns="0" rIns="0" bIns="0" rtlCol="0" anchor="ctr"/>
           <a:lstStyle/>
           <a:p>
-            <a:pPr indent="0" marL="0">
+            <a:pPr marL="0" indent="0">
               <a:buNone/>
             </a:pPr>
             <a:r>
@@ -2730,7 +2520,7 @@
           <a:bodyPr wrap="square" lIns="0" tIns="0" rIns="0" bIns="0" rtlCol="0" anchor="ctr"/>
           <a:lstStyle/>
           <a:p>
-            <a:pPr indent="0" marL="0">
+            <a:pPr marL="0" indent="0">
               <a:buNone/>
             </a:pPr>
             <a:r>
@@ -2791,7 +2581,7 @@
           <a:bodyPr wrap="square" lIns="0" tIns="0" rIns="0" bIns="0" rtlCol="0" anchor="ctr"/>
           <a:lstStyle/>
           <a:p>
-            <a:pPr indent="0" marL="0">
+            <a:pPr marL="0" indent="0">
               <a:buNone/>
             </a:pPr>
             <a:r>
@@ -2852,7 +2642,7 @@
           <a:bodyPr wrap="square" lIns="0" tIns="0" rIns="0" bIns="0" rtlCol="0" anchor="ctr"/>
           <a:lstStyle/>
           <a:p>
-            <a:pPr indent="0" marL="0">
+            <a:pPr marL="0" indent="0">
               <a:buNone/>
             </a:pPr>
             <a:r>
@@ -2913,7 +2703,7 @@
           <a:bodyPr wrap="square" lIns="0" tIns="0" rIns="0" bIns="0" rtlCol="0" anchor="ctr"/>
           <a:lstStyle/>
           <a:p>
-            <a:pPr indent="0" marL="0">
+            <a:pPr marL="0" indent="0">
               <a:buNone/>
             </a:pPr>
             <a:r>
@@ -2954,7 +2744,7 @@
             <a:prstDash val="solid"/>
           </a:ln>
           <a:effectLst>
-            <a:outerShdw sx="100000" sy="100000" kx="0" ky="0" algn="bl" rotWithShape="0" blurRad="101600" dist="38100" dir="2700000">
+            <a:outerShdw blurRad="101600" dist="38100" dir="2700000" algn="bl" rotWithShape="0">
               <a:srgbClr val="000000">
                 <a:alpha val="12000"/>
               </a:srgbClr>
@@ -3035,7 +2825,7 @@
           <a:bodyPr wrap="square" lIns="0" tIns="0" rIns="0" bIns="0" rtlCol="0" anchor="ctr"/>
           <a:lstStyle/>
           <a:p>
-            <a:pPr algn="ctr" indent="0" marL="0">
+            <a:pPr marL="0" indent="0" algn="ctr">
               <a:buNone/>
             </a:pPr>
             <a:r>
@@ -3096,7 +2886,7 @@
           <a:bodyPr wrap="square" lIns="0" tIns="0" rIns="0" bIns="0" rtlCol="0" anchor="ctr"/>
           <a:lstStyle/>
           <a:p>
-            <a:pPr indent="0" marL="0">
+            <a:pPr marL="0" indent="0">
               <a:buNone/>
             </a:pPr>
             <a:r>
@@ -3157,7 +2947,7 @@
           <a:bodyPr wrap="square" lIns="0" tIns="0" rIns="0" bIns="0" rtlCol="0" anchor="ctr"/>
           <a:lstStyle/>
           <a:p>
-            <a:pPr indent="0" marL="0">
+            <a:pPr marL="0" indent="0">
               <a:buNone/>
             </a:pPr>
             <a:r>
@@ -3218,7 +3008,7 @@
           <a:bodyPr wrap="square" lIns="0" tIns="0" rIns="0" bIns="0" rtlCol="0" anchor="ctr"/>
           <a:lstStyle/>
           <a:p>
-            <a:pPr indent="0" marL="0">
+            <a:pPr marL="0" indent="0">
               <a:buNone/>
             </a:pPr>
             <a:r>
@@ -3279,7 +3069,7 @@
           <a:bodyPr wrap="square" lIns="0" tIns="0" rIns="0" bIns="0" rtlCol="0" anchor="ctr"/>
           <a:lstStyle/>
           <a:p>
-            <a:pPr indent="0" marL="0">
+            <a:pPr marL="0" indent="0">
               <a:buNone/>
             </a:pPr>
             <a:r>
@@ -3340,7 +3130,7 @@
           <a:bodyPr wrap="square" lIns="0" tIns="0" rIns="0" bIns="0" rtlCol="0" anchor="ctr"/>
           <a:lstStyle/>
           <a:p>
-            <a:pPr indent="0" marL="0">
+            <a:pPr marL="0" indent="0">
               <a:buNone/>
             </a:pPr>
             <a:r>
@@ -3371,6 +3161,7 @@
         <a:solidFill>
           <a:srgbClr val="0A1628"/>
         </a:solidFill>
+        <a:effectLst/>
       </p:bgPr>
     </p:bg>
     <p:spTree>
@@ -3466,7 +3257,7 @@
           <a:bodyPr wrap="square" rtlCol="0" anchor="ctr"/>
           <a:lstStyle/>
           <a:p>
-            <a:pPr algn="ctr" indent="0" marL="0">
+            <a:pPr marL="0" indent="0" algn="ctr">
               <a:buNone/>
             </a:pPr>
             <a:r>
@@ -3502,7 +3293,7 @@
           <a:bodyPr wrap="square" rtlCol="0" anchor="ctr"/>
           <a:lstStyle/>
           <a:p>
-            <a:pPr algn="ctr" indent="0" marL="0">
+            <a:pPr marL="0" indent="0" algn="ctr">
               <a:buNone/>
             </a:pPr>
             <a:r>
@@ -3563,7 +3354,7 @@
           <a:bodyPr wrap="square" rtlCol="0" anchor="ctr"/>
           <a:lstStyle/>
           <a:p>
-            <a:pPr algn="ctr" indent="0" marL="0">
+            <a:pPr marL="0" indent="0" algn="ctr">
               <a:buNone/>
             </a:pPr>
             <a:r>
@@ -3574,9 +3365,6 @@
               </a:rPr>
               <a:t>🌐  Live App: </a:t>
             </a:r>
-            <a:pPr algn="ctr" indent="0" marL="0">
-              <a:buNone/>
-            </a:pPr>
             <a:r>
               <a:rPr lang="en-US" sz="1300" dirty="0">
                 <a:solidFill>
@@ -3610,7 +3398,7 @@
           <a:bodyPr wrap="square" rtlCol="0" anchor="ctr"/>
           <a:lstStyle/>
           <a:p>
-            <a:pPr algn="ctr" indent="0" marL="0">
+            <a:pPr marL="0" indent="0" algn="ctr">
               <a:buNone/>
             </a:pPr>
             <a:r>
@@ -3621,9 +3409,6 @@
               </a:rPr>
               <a:t>Jeevan Kumar Gujja  </a:t>
             </a:r>
-            <a:pPr algn="ctr" indent="0" marL="0">
-              <a:buNone/>
-            </a:pPr>
             <a:r>
               <a:rPr lang="en-US" sz="1200" dirty="0">
                 <a:solidFill>
@@ -3652,6 +3437,7 @@
         <a:solidFill>
           <a:srgbClr val="FFFFFF"/>
         </a:solidFill>
+        <a:effectLst/>
       </p:bgPr>
     </p:bg>
     <p:spTree>
@@ -3689,7 +3475,7 @@
           <a:bodyPr wrap="square" rtlCol="0" anchor="ctr"/>
           <a:lstStyle/>
           <a:p>
-            <a:pPr indent="0" marL="0">
+            <a:pPr marL="0" indent="0">
               <a:buNone/>
             </a:pPr>
             <a:r>
@@ -3804,7 +3590,7 @@
           <a:bodyPr wrap="square" lIns="0" tIns="0" rIns="0" bIns="0" rtlCol="0" anchor="ctr"/>
           <a:lstStyle/>
           <a:p>
-            <a:pPr algn="ctr" indent="0" marL="0">
+            <a:pPr marL="0" indent="0" algn="ctr">
               <a:buNone/>
             </a:pPr>
             <a:r>
@@ -3840,7 +3626,7 @@
           <a:bodyPr wrap="square" lIns="0" tIns="0" rIns="0" bIns="0" rtlCol="0" anchor="ctr"/>
           <a:lstStyle/>
           <a:p>
-            <a:pPr indent="0" marL="0">
+            <a:pPr marL="0" indent="0">
               <a:buNone/>
             </a:pPr>
             <a:r>
@@ -3876,7 +3662,7 @@
           <a:bodyPr wrap="square" lIns="0" tIns="0" rIns="0" bIns="0" rtlCol="0" anchor="ctr"/>
           <a:lstStyle/>
           <a:p>
-            <a:pPr indent="0" marL="0">
+            <a:pPr marL="0" indent="0">
               <a:buNone/>
             </a:pPr>
             <a:r>
@@ -3966,7 +3752,7 @@
           <a:bodyPr wrap="square" lIns="0" tIns="0" rIns="0" bIns="0" rtlCol="0" anchor="ctr"/>
           <a:lstStyle/>
           <a:p>
-            <a:pPr algn="ctr" indent="0" marL="0">
+            <a:pPr marL="0" indent="0" algn="ctr">
               <a:buNone/>
             </a:pPr>
             <a:r>
@@ -4002,7 +3788,7 @@
           <a:bodyPr wrap="square" lIns="0" tIns="0" rIns="0" bIns="0" rtlCol="0" anchor="ctr"/>
           <a:lstStyle/>
           <a:p>
-            <a:pPr indent="0" marL="0">
+            <a:pPr marL="0" indent="0">
               <a:buNone/>
             </a:pPr>
             <a:r>
@@ -4038,7 +3824,7 @@
           <a:bodyPr wrap="square" lIns="0" tIns="0" rIns="0" bIns="0" rtlCol="0" anchor="ctr"/>
           <a:lstStyle/>
           <a:p>
-            <a:pPr indent="0" marL="0">
+            <a:pPr marL="0" indent="0">
               <a:buNone/>
             </a:pPr>
             <a:r>
@@ -4128,7 +3914,7 @@
           <a:bodyPr wrap="square" lIns="0" tIns="0" rIns="0" bIns="0" rtlCol="0" anchor="ctr"/>
           <a:lstStyle/>
           <a:p>
-            <a:pPr algn="ctr" indent="0" marL="0">
+            <a:pPr marL="0" indent="0" algn="ctr">
               <a:buNone/>
             </a:pPr>
             <a:r>
@@ -4164,7 +3950,7 @@
           <a:bodyPr wrap="square" lIns="0" tIns="0" rIns="0" bIns="0" rtlCol="0" anchor="ctr"/>
           <a:lstStyle/>
           <a:p>
-            <a:pPr indent="0" marL="0">
+            <a:pPr marL="0" indent="0">
               <a:buNone/>
             </a:pPr>
             <a:r>
@@ -4200,7 +3986,7 @@
           <a:bodyPr wrap="square" lIns="0" tIns="0" rIns="0" bIns="0" rtlCol="0" anchor="ctr"/>
           <a:lstStyle/>
           <a:p>
-            <a:pPr indent="0" marL="0">
+            <a:pPr marL="0" indent="0">
               <a:buNone/>
             </a:pPr>
             <a:r>
@@ -4290,7 +4076,7 @@
           <a:bodyPr wrap="square" lIns="0" tIns="0" rIns="0" bIns="0" rtlCol="0" anchor="ctr"/>
           <a:lstStyle/>
           <a:p>
-            <a:pPr algn="ctr" indent="0" marL="0">
+            <a:pPr marL="0" indent="0" algn="ctr">
               <a:buNone/>
             </a:pPr>
             <a:r>
@@ -4326,7 +4112,7 @@
           <a:bodyPr wrap="square" lIns="0" tIns="0" rIns="0" bIns="0" rtlCol="0" anchor="ctr"/>
           <a:lstStyle/>
           <a:p>
-            <a:pPr indent="0" marL="0">
+            <a:pPr marL="0" indent="0">
               <a:buNone/>
             </a:pPr>
             <a:r>
@@ -4362,7 +4148,7 @@
           <a:bodyPr wrap="square" lIns="0" tIns="0" rIns="0" bIns="0" rtlCol="0" anchor="ctr"/>
           <a:lstStyle/>
           <a:p>
-            <a:pPr indent="0" marL="0">
+            <a:pPr marL="0" indent="0">
               <a:buNone/>
             </a:pPr>
             <a:r>
@@ -4452,7 +4238,7 @@
           <a:bodyPr wrap="square" lIns="0" tIns="0" rIns="0" bIns="0" rtlCol="0" anchor="ctr"/>
           <a:lstStyle/>
           <a:p>
-            <a:pPr algn="ctr" indent="0" marL="0">
+            <a:pPr marL="0" indent="0" algn="ctr">
               <a:buNone/>
             </a:pPr>
             <a:r>
@@ -4488,7 +4274,7 @@
           <a:bodyPr wrap="square" lIns="0" tIns="0" rIns="0" bIns="0" rtlCol="0" anchor="ctr"/>
           <a:lstStyle/>
           <a:p>
-            <a:pPr indent="0" marL="0">
+            <a:pPr marL="0" indent="0">
               <a:buNone/>
             </a:pPr>
             <a:r>
@@ -4524,7 +4310,7 @@
           <a:bodyPr wrap="square" lIns="0" tIns="0" rIns="0" bIns="0" rtlCol="0" anchor="ctr"/>
           <a:lstStyle/>
           <a:p>
-            <a:pPr indent="0" marL="0">
+            <a:pPr marL="0" indent="0">
               <a:buNone/>
             </a:pPr>
             <a:r>
@@ -4555,6 +4341,7 @@
         <a:solidFill>
           <a:srgbClr val="FFFFFF"/>
         </a:solidFill>
+        <a:effectLst/>
       </p:bgPr>
     </p:bg>
     <p:spTree>
@@ -4592,7 +4379,7 @@
           <a:bodyPr wrap="square" rtlCol="0" anchor="ctr"/>
           <a:lstStyle/>
           <a:p>
-            <a:pPr indent="0" marL="0">
+            <a:pPr marL="0" indent="0">
               <a:buNone/>
             </a:pPr>
             <a:r>
@@ -4628,7 +4415,7 @@
           <a:bodyPr wrap="square" rtlCol="0" anchor="ctr"/>
           <a:lstStyle/>
           <a:p>
-            <a:pPr indent="0" marL="0">
+            <a:pPr marL="0" indent="0">
               <a:buNone/>
             </a:pPr>
             <a:r>
@@ -4669,7 +4456,7 @@
             <a:prstDash val="solid"/>
           </a:ln>
           <a:effectLst>
-            <a:outerShdw sx="100000" sy="100000" kx="0" ky="0" algn="bl" rotWithShape="0" blurRad="101600" dist="38100" dir="2700000">
+            <a:outerShdw blurRad="101600" dist="38100" dir="2700000" algn="bl" rotWithShape="0">
               <a:srgbClr val="000000">
                 <a:alpha val="12000"/>
               </a:srgbClr>
@@ -4725,7 +4512,7 @@
           <a:bodyPr wrap="square" lIns="0" tIns="0" rIns="0" bIns="0" rtlCol="0" anchor="ctr"/>
           <a:lstStyle/>
           <a:p>
-            <a:pPr algn="ctr" indent="0" marL="0">
+            <a:pPr marL="0" indent="0" algn="ctr">
               <a:buNone/>
             </a:pPr>
             <a:r>
@@ -4761,7 +4548,7 @@
           <a:bodyPr wrap="square" lIns="0" tIns="0" rIns="0" bIns="0" rtlCol="0" anchor="ctr"/>
           <a:lstStyle/>
           <a:p>
-            <a:pPr algn="ctr" indent="0" marL="0">
+            <a:pPr marL="0" indent="0" algn="ctr">
               <a:buNone/>
             </a:pPr>
             <a:r>
@@ -4802,7 +4589,7 @@
             <a:prstDash val="solid"/>
           </a:ln>
           <a:effectLst>
-            <a:outerShdw sx="100000" sy="100000" kx="0" ky="0" algn="bl" rotWithShape="0" blurRad="101600" dist="38100" dir="2700000">
+            <a:outerShdw blurRad="101600" dist="38100" dir="2700000" algn="bl" rotWithShape="0">
               <a:srgbClr val="000000">
                 <a:alpha val="12000"/>
               </a:srgbClr>
@@ -4858,7 +4645,7 @@
           <a:bodyPr wrap="square" lIns="0" tIns="0" rIns="0" bIns="0" rtlCol="0" anchor="ctr"/>
           <a:lstStyle/>
           <a:p>
-            <a:pPr algn="ctr" indent="0" marL="0">
+            <a:pPr marL="0" indent="0" algn="ctr">
               <a:buNone/>
             </a:pPr>
             <a:r>
@@ -4894,7 +4681,7 @@
           <a:bodyPr wrap="square" lIns="0" tIns="0" rIns="0" bIns="0" rtlCol="0" anchor="ctr"/>
           <a:lstStyle/>
           <a:p>
-            <a:pPr algn="ctr" indent="0" marL="0">
+            <a:pPr marL="0" indent="0" algn="ctr">
               <a:buNone/>
             </a:pPr>
             <a:r>
@@ -4935,7 +4722,7 @@
             <a:prstDash val="solid"/>
           </a:ln>
           <a:effectLst>
-            <a:outerShdw sx="100000" sy="100000" kx="0" ky="0" algn="bl" rotWithShape="0" blurRad="101600" dist="38100" dir="2700000">
+            <a:outerShdw blurRad="101600" dist="38100" dir="2700000" algn="bl" rotWithShape="0">
               <a:srgbClr val="000000">
                 <a:alpha val="12000"/>
               </a:srgbClr>
@@ -4991,7 +4778,7 @@
           <a:bodyPr wrap="square" lIns="0" tIns="0" rIns="0" bIns="0" rtlCol="0" anchor="ctr"/>
           <a:lstStyle/>
           <a:p>
-            <a:pPr algn="ctr" indent="0" marL="0">
+            <a:pPr marL="0" indent="0" algn="ctr">
               <a:buNone/>
             </a:pPr>
             <a:r>
@@ -5027,7 +4814,7 @@
           <a:bodyPr wrap="square" lIns="0" tIns="0" rIns="0" bIns="0" rtlCol="0" anchor="ctr"/>
           <a:lstStyle/>
           <a:p>
-            <a:pPr algn="ctr" indent="0" marL="0">
+            <a:pPr marL="0" indent="0" algn="ctr">
               <a:buNone/>
             </a:pPr>
             <a:r>
@@ -5068,7 +4855,7 @@
             <a:prstDash val="solid"/>
           </a:ln>
           <a:effectLst>
-            <a:outerShdw sx="100000" sy="100000" kx="0" ky="0" algn="bl" rotWithShape="0" blurRad="101600" dist="38100" dir="2700000">
+            <a:outerShdw blurRad="101600" dist="38100" dir="2700000" algn="bl" rotWithShape="0">
               <a:srgbClr val="000000">
                 <a:alpha val="12000"/>
               </a:srgbClr>
@@ -5124,7 +4911,7 @@
           <a:bodyPr wrap="square" lIns="0" tIns="0" rIns="0" bIns="0" rtlCol="0" anchor="ctr"/>
           <a:lstStyle/>
           <a:p>
-            <a:pPr algn="ctr" indent="0" marL="0">
+            <a:pPr marL="0" indent="0" algn="ctr">
               <a:buNone/>
             </a:pPr>
             <a:r>
@@ -5160,7 +4947,7 @@
           <a:bodyPr wrap="square" lIns="0" tIns="0" rIns="0" bIns="0" rtlCol="0" anchor="ctr"/>
           <a:lstStyle/>
           <a:p>
-            <a:pPr algn="ctr" indent="0" marL="0">
+            <a:pPr marL="0" indent="0" algn="ctr">
               <a:buNone/>
             </a:pPr>
             <a:r>
@@ -5201,7 +4988,7 @@
             <a:prstDash val="solid"/>
           </a:ln>
           <a:effectLst>
-            <a:outerShdw sx="100000" sy="100000" kx="0" ky="0" algn="bl" rotWithShape="0" blurRad="101600" dist="38100" dir="2700000">
+            <a:outerShdw blurRad="101600" dist="38100" dir="2700000" algn="bl" rotWithShape="0">
               <a:srgbClr val="000000">
                 <a:alpha val="12000"/>
               </a:srgbClr>
@@ -5257,7 +5044,7 @@
           <a:bodyPr wrap="square" lIns="0" tIns="0" rIns="0" bIns="0" rtlCol="0" anchor="ctr"/>
           <a:lstStyle/>
           <a:p>
-            <a:pPr algn="ctr" indent="0" marL="0">
+            <a:pPr marL="0" indent="0" algn="ctr">
               <a:buNone/>
             </a:pPr>
             <a:r>
@@ -5293,7 +5080,7 @@
           <a:bodyPr wrap="square" lIns="0" tIns="0" rIns="0" bIns="0" rtlCol="0" anchor="ctr"/>
           <a:lstStyle/>
           <a:p>
-            <a:pPr algn="ctr" indent="0" marL="0">
+            <a:pPr marL="0" indent="0" algn="ctr">
               <a:buNone/>
             </a:pPr>
             <a:r>
@@ -5334,7 +5121,7 @@
             <a:prstDash val="solid"/>
           </a:ln>
           <a:effectLst>
-            <a:outerShdw sx="100000" sy="100000" kx="0" ky="0" algn="bl" rotWithShape="0" blurRad="101600" dist="38100" dir="2700000">
+            <a:outerShdw blurRad="101600" dist="38100" dir="2700000" algn="bl" rotWithShape="0">
               <a:srgbClr val="000000">
                 <a:alpha val="12000"/>
               </a:srgbClr>
@@ -5390,7 +5177,7 @@
           <a:bodyPr wrap="square" lIns="0" tIns="0" rIns="0" bIns="0" rtlCol="0" anchor="ctr"/>
           <a:lstStyle/>
           <a:p>
-            <a:pPr algn="ctr" indent="0" marL="0">
+            <a:pPr marL="0" indent="0" algn="ctr">
               <a:buNone/>
             </a:pPr>
             <a:r>
@@ -5426,7 +5213,7 @@
           <a:bodyPr wrap="square" lIns="0" tIns="0" rIns="0" bIns="0" rtlCol="0" anchor="ctr"/>
           <a:lstStyle/>
           <a:p>
-            <a:pPr algn="ctr" indent="0" marL="0">
+            <a:pPr marL="0" indent="0" algn="ctr">
               <a:buNone/>
             </a:pPr>
             <a:r>
@@ -5467,7 +5254,7 @@
             <a:prstDash val="solid"/>
           </a:ln>
           <a:effectLst>
-            <a:outerShdw sx="100000" sy="100000" kx="0" ky="0" algn="bl" rotWithShape="0" blurRad="101600" dist="38100" dir="2700000">
+            <a:outerShdw blurRad="101600" dist="38100" dir="2700000" algn="bl" rotWithShape="0">
               <a:srgbClr val="000000">
                 <a:alpha val="12000"/>
               </a:srgbClr>
@@ -5523,7 +5310,7 @@
           <a:bodyPr wrap="square" lIns="0" tIns="0" rIns="0" bIns="0" rtlCol="0" anchor="ctr"/>
           <a:lstStyle/>
           <a:p>
-            <a:pPr algn="ctr" indent="0" marL="0">
+            <a:pPr marL="0" indent="0" algn="ctr">
               <a:buNone/>
             </a:pPr>
             <a:r>
@@ -5559,7 +5346,7 @@
           <a:bodyPr wrap="square" lIns="0" tIns="0" rIns="0" bIns="0" rtlCol="0" anchor="ctr"/>
           <a:lstStyle/>
           <a:p>
-            <a:pPr algn="ctr" indent="0" marL="0">
+            <a:pPr marL="0" indent="0" algn="ctr">
               <a:buNone/>
             </a:pPr>
             <a:r>
@@ -5600,7 +5387,7 @@
             <a:prstDash val="solid"/>
           </a:ln>
           <a:effectLst>
-            <a:outerShdw sx="100000" sy="100000" kx="0" ky="0" algn="bl" rotWithShape="0" blurRad="101600" dist="38100" dir="2700000">
+            <a:outerShdw blurRad="101600" dist="38100" dir="2700000" algn="bl" rotWithShape="0">
               <a:srgbClr val="000000">
                 <a:alpha val="12000"/>
               </a:srgbClr>
@@ -5656,7 +5443,7 @@
           <a:bodyPr wrap="square" lIns="0" tIns="0" rIns="0" bIns="0" rtlCol="0" anchor="ctr"/>
           <a:lstStyle/>
           <a:p>
-            <a:pPr algn="ctr" indent="0" marL="0">
+            <a:pPr marL="0" indent="0" algn="ctr">
               <a:buNone/>
             </a:pPr>
             <a:r>
@@ -5692,7 +5479,7 @@
           <a:bodyPr wrap="square" lIns="0" tIns="0" rIns="0" bIns="0" rtlCol="0" anchor="ctr"/>
           <a:lstStyle/>
           <a:p>
-            <a:pPr algn="ctr" indent="0" marL="0">
+            <a:pPr marL="0" indent="0" algn="ctr">
               <a:buNone/>
             </a:pPr>
             <a:r>
@@ -5723,6 +5510,7 @@
         <a:solidFill>
           <a:srgbClr val="0A1628"/>
         </a:solidFill>
+        <a:effectLst/>
       </p:bgPr>
     </p:bg>
     <p:spTree>
@@ -5787,7 +5575,7 @@
           <a:bodyPr wrap="square" lIns="0" tIns="0" rIns="0" bIns="0" rtlCol="0" anchor="ctr"/>
           <a:lstStyle/>
           <a:p>
-            <a:pPr algn="ctr" indent="0" marL="0">
+            <a:pPr marL="0" indent="0" algn="ctr">
               <a:buNone/>
             </a:pPr>
             <a:r>
@@ -5823,7 +5611,7 @@
           <a:bodyPr wrap="square" rtlCol="0" anchor="ctr"/>
           <a:lstStyle/>
           <a:p>
-            <a:pPr indent="0" marL="0">
+            <a:pPr marL="0" indent="0">
               <a:buNone/>
             </a:pPr>
             <a:r>
@@ -5859,7 +5647,7 @@
           <a:bodyPr wrap="square" rtlCol="0" anchor="ctr"/>
           <a:lstStyle/>
           <a:p>
-            <a:pPr indent="0" marL="0">
+            <a:pPr marL="0" indent="0">
               <a:buNone/>
             </a:pPr>
             <a:r>
@@ -5922,7 +5710,7 @@
           <a:bodyPr wrap="square" lIns="0" tIns="0" rIns="0" bIns="0" rtlCol="0" anchor="ctr"/>
           <a:lstStyle/>
           <a:p>
-            <a:pPr indent="0" marL="0">
+            <a:pPr marL="0" indent="0">
               <a:buNone/>
             </a:pPr>
             <a:r>
@@ -5958,7 +5746,7 @@
           <a:bodyPr wrap="square" lIns="0" tIns="0" rIns="0" bIns="0" rtlCol="0" anchor="ctr"/>
           <a:lstStyle/>
           <a:p>
-            <a:pPr indent="0" marL="0">
+            <a:pPr marL="0" indent="0">
               <a:buNone/>
             </a:pPr>
             <a:r>
@@ -5972,7 +5760,7 @@
             <a:endParaRPr lang="en-US" sz="1100" dirty="0"/>
           </a:p>
           <a:p>
-            <a:pPr indent="0" marL="0">
+            <a:pPr marL="0" indent="0">
               <a:buNone/>
             </a:pPr>
             <a:r>
@@ -5986,7 +5774,7 @@
             <a:endParaRPr lang="en-US" sz="1100" dirty="0"/>
           </a:p>
           <a:p>
-            <a:pPr indent="0" marL="0">
+            <a:pPr marL="0" indent="0">
               <a:buNone/>
             </a:pPr>
             <a:r>
@@ -6049,7 +5837,7 @@
           <a:bodyPr wrap="square" lIns="0" tIns="0" rIns="0" bIns="0" rtlCol="0" anchor="ctr"/>
           <a:lstStyle/>
           <a:p>
-            <a:pPr indent="0" marL="0">
+            <a:pPr marL="0" indent="0">
               <a:buNone/>
             </a:pPr>
             <a:r>
@@ -6085,7 +5873,7 @@
           <a:bodyPr wrap="square" lIns="0" tIns="0" rIns="0" bIns="0" rtlCol="0" anchor="ctr"/>
           <a:lstStyle/>
           <a:p>
-            <a:pPr indent="0" marL="0">
+            <a:pPr marL="0" indent="0">
               <a:buNone/>
             </a:pPr>
             <a:r>
@@ -6099,7 +5887,7 @@
             <a:endParaRPr lang="en-US" sz="1100" dirty="0"/>
           </a:p>
           <a:p>
-            <a:pPr indent="0" marL="0">
+            <a:pPr marL="0" indent="0">
               <a:buNone/>
             </a:pPr>
             <a:r>
@@ -6113,7 +5901,7 @@
             <a:endParaRPr lang="en-US" sz="1100" dirty="0"/>
           </a:p>
           <a:p>
-            <a:pPr indent="0" marL="0">
+            <a:pPr marL="0" indent="0">
               <a:buNone/>
             </a:pPr>
             <a:r>
@@ -6176,7 +5964,7 @@
           <a:bodyPr wrap="square" lIns="0" tIns="0" rIns="0" bIns="0" rtlCol="0" anchor="ctr"/>
           <a:lstStyle/>
           <a:p>
-            <a:pPr indent="0" marL="0">
+            <a:pPr marL="0" indent="0">
               <a:buNone/>
             </a:pPr>
             <a:r>
@@ -6212,7 +6000,7 @@
           <a:bodyPr wrap="square" lIns="0" tIns="0" rIns="0" bIns="0" rtlCol="0" anchor="ctr"/>
           <a:lstStyle/>
           <a:p>
-            <a:pPr indent="0" marL="0">
+            <a:pPr marL="0" indent="0">
               <a:buNone/>
             </a:pPr>
             <a:r>
@@ -6226,7 +6014,7 @@
             <a:endParaRPr lang="en-US" sz="1100" dirty="0"/>
           </a:p>
           <a:p>
-            <a:pPr indent="0" marL="0">
+            <a:pPr marL="0" indent="0">
               <a:buNone/>
             </a:pPr>
             <a:r>
@@ -6240,7 +6028,7 @@
             <a:endParaRPr lang="en-US" sz="1100" dirty="0"/>
           </a:p>
           <a:p>
-            <a:pPr indent="0" marL="0">
+            <a:pPr marL="0" indent="0">
               <a:buNone/>
             </a:pPr>
             <a:r>
@@ -6303,7 +6091,7 @@
           <a:bodyPr wrap="square" lIns="0" tIns="0" rIns="0" bIns="0" rtlCol="0" anchor="ctr"/>
           <a:lstStyle/>
           <a:p>
-            <a:pPr indent="0" marL="0">
+            <a:pPr marL="0" indent="0">
               <a:buNone/>
             </a:pPr>
             <a:r>
@@ -6339,7 +6127,7 @@
           <a:bodyPr wrap="square" lIns="0" tIns="0" rIns="0" bIns="0" rtlCol="0" anchor="ctr"/>
           <a:lstStyle/>
           <a:p>
-            <a:pPr indent="0" marL="0">
+            <a:pPr marL="0" indent="0">
               <a:buNone/>
             </a:pPr>
             <a:r>
@@ -6353,7 +6141,7 @@
             <a:endParaRPr lang="en-US" sz="1100" dirty="0"/>
           </a:p>
           <a:p>
-            <a:pPr indent="0" marL="0">
+            <a:pPr marL="0" indent="0">
               <a:buNone/>
             </a:pPr>
             <a:r>
@@ -6367,7 +6155,7 @@
             <a:endParaRPr lang="en-US" sz="1100" dirty="0"/>
           </a:p>
           <a:p>
-            <a:pPr indent="0" marL="0">
+            <a:pPr marL="0" indent="0">
               <a:buNone/>
             </a:pPr>
             <a:r>
@@ -6398,6 +6186,7 @@
         <a:solidFill>
           <a:srgbClr val="FFFFFF"/>
         </a:solidFill>
+        <a:effectLst/>
       </p:bgPr>
     </p:bg>
     <p:spTree>
@@ -6462,7 +6251,7 @@
           <a:bodyPr wrap="square" lIns="0" tIns="0" rIns="0" bIns="0" rtlCol="0" anchor="ctr"/>
           <a:lstStyle/>
           <a:p>
-            <a:pPr algn="ctr" indent="0" marL="0">
+            <a:pPr marL="0" indent="0" algn="ctr">
               <a:buNone/>
             </a:pPr>
             <a:r>
@@ -6498,7 +6287,7 @@
           <a:bodyPr wrap="square" rtlCol="0" anchor="ctr"/>
           <a:lstStyle/>
           <a:p>
-            <a:pPr indent="0" marL="0">
+            <a:pPr marL="0" indent="0">
               <a:buNone/>
             </a:pPr>
             <a:r>
@@ -6534,7 +6323,7 @@
           <a:bodyPr wrap="square" rtlCol="0" anchor="ctr"/>
           <a:lstStyle/>
           <a:p>
-            <a:pPr indent="0" marL="0">
+            <a:pPr marL="0" indent="0">
               <a:buNone/>
             </a:pPr>
             <a:r>
@@ -6575,7 +6364,7 @@
             <a:prstDash val="solid"/>
           </a:ln>
           <a:effectLst>
-            <a:outerShdw sx="100000" sy="100000" kx="0" ky="0" algn="bl" rotWithShape="0" blurRad="101600" dist="38100" dir="2700000">
+            <a:outerShdw blurRad="101600" dist="38100" dir="2700000" algn="bl" rotWithShape="0">
               <a:srgbClr val="000000">
                 <a:alpha val="12000"/>
               </a:srgbClr>
@@ -6604,7 +6393,7 @@
           <a:bodyPr wrap="square" lIns="0" tIns="0" rIns="0" bIns="0" rtlCol="0" anchor="ctr"/>
           <a:lstStyle/>
           <a:p>
-            <a:pPr indent="0" marL="0">
+            <a:pPr marL="0" indent="0">
               <a:buNone/>
             </a:pPr>
             <a:r>
@@ -6640,7 +6429,7 @@
           <a:bodyPr wrap="square" lIns="0" tIns="0" rIns="0" bIns="0" rtlCol="0" anchor="ctr"/>
           <a:lstStyle/>
           <a:p>
-            <a:pPr indent="0" marL="0">
+            <a:pPr marL="0" indent="0">
               <a:buNone/>
             </a:pPr>
             <a:r>
@@ -6654,7 +6443,7 @@
             <a:endParaRPr lang="en-US" sz="1100" dirty="0"/>
           </a:p>
           <a:p>
-            <a:pPr indent="0" marL="0">
+            <a:pPr marL="0" indent="0">
               <a:buNone/>
             </a:pPr>
             <a:r>
@@ -6695,7 +6484,7 @@
             <a:prstDash val="solid"/>
           </a:ln>
           <a:effectLst>
-            <a:outerShdw sx="100000" sy="100000" kx="0" ky="0" algn="bl" rotWithShape="0" blurRad="101600" dist="38100" dir="2700000">
+            <a:outerShdw blurRad="101600" dist="38100" dir="2700000" algn="bl" rotWithShape="0">
               <a:srgbClr val="000000">
                 <a:alpha val="12000"/>
               </a:srgbClr>
@@ -6724,7 +6513,7 @@
           <a:bodyPr wrap="square" lIns="0" tIns="0" rIns="0" bIns="0" rtlCol="0" anchor="ctr"/>
           <a:lstStyle/>
           <a:p>
-            <a:pPr indent="0" marL="0">
+            <a:pPr marL="0" indent="0">
               <a:buNone/>
             </a:pPr>
             <a:r>
@@ -6760,7 +6549,7 @@
           <a:bodyPr wrap="square" lIns="0" tIns="0" rIns="0" bIns="0" rtlCol="0" anchor="ctr"/>
           <a:lstStyle/>
           <a:p>
-            <a:pPr indent="0" marL="0">
+            <a:pPr marL="0" indent="0">
               <a:buNone/>
             </a:pPr>
             <a:r>
@@ -6774,7 +6563,7 @@
             <a:endParaRPr lang="en-US" sz="1100" dirty="0"/>
           </a:p>
           <a:p>
-            <a:pPr indent="0" marL="0">
+            <a:pPr marL="0" indent="0">
               <a:buNone/>
             </a:pPr>
             <a:r>
@@ -6815,7 +6604,7 @@
             <a:prstDash val="solid"/>
           </a:ln>
           <a:effectLst>
-            <a:outerShdw sx="100000" sy="100000" kx="0" ky="0" algn="bl" rotWithShape="0" blurRad="101600" dist="38100" dir="2700000">
+            <a:outerShdw blurRad="101600" dist="38100" dir="2700000" algn="bl" rotWithShape="0">
               <a:srgbClr val="000000">
                 <a:alpha val="12000"/>
               </a:srgbClr>
@@ -6844,7 +6633,7 @@
           <a:bodyPr wrap="square" lIns="0" tIns="0" rIns="0" bIns="0" rtlCol="0" anchor="ctr"/>
           <a:lstStyle/>
           <a:p>
-            <a:pPr indent="0" marL="0">
+            <a:pPr marL="0" indent="0">
               <a:buNone/>
             </a:pPr>
             <a:r>
@@ -6880,7 +6669,7 @@
           <a:bodyPr wrap="square" lIns="0" tIns="0" rIns="0" bIns="0" rtlCol="0" anchor="ctr"/>
           <a:lstStyle/>
           <a:p>
-            <a:pPr indent="0" marL="0">
+            <a:pPr marL="0" indent="0">
               <a:buNone/>
             </a:pPr>
             <a:r>
@@ -6894,7 +6683,7 @@
             <a:endParaRPr lang="en-US" sz="1100" dirty="0"/>
           </a:p>
           <a:p>
-            <a:pPr indent="0" marL="0">
+            <a:pPr marL="0" indent="0">
               <a:buNone/>
             </a:pPr>
             <a:r>
@@ -6935,7 +6724,7 @@
             <a:prstDash val="solid"/>
           </a:ln>
           <a:effectLst>
-            <a:outerShdw sx="100000" sy="100000" kx="0" ky="0" algn="bl" rotWithShape="0" blurRad="101600" dist="38100" dir="2700000">
+            <a:outerShdw blurRad="101600" dist="38100" dir="2700000" algn="bl" rotWithShape="0">
               <a:srgbClr val="000000">
                 <a:alpha val="12000"/>
               </a:srgbClr>
@@ -6964,7 +6753,7 @@
           <a:bodyPr wrap="square" lIns="0" tIns="0" rIns="0" bIns="0" rtlCol="0" anchor="ctr"/>
           <a:lstStyle/>
           <a:p>
-            <a:pPr indent="0" marL="0">
+            <a:pPr marL="0" indent="0">
               <a:buNone/>
             </a:pPr>
             <a:r>
@@ -7000,7 +6789,7 @@
           <a:bodyPr wrap="square" lIns="0" tIns="0" rIns="0" bIns="0" rtlCol="0" anchor="ctr"/>
           <a:lstStyle/>
           <a:p>
-            <a:pPr indent="0" marL="0">
+            <a:pPr marL="0" indent="0">
               <a:buNone/>
             </a:pPr>
             <a:r>
@@ -7014,7 +6803,7 @@
             <a:endParaRPr lang="en-US" sz="1100" dirty="0"/>
           </a:p>
           <a:p>
-            <a:pPr indent="0" marL="0">
+            <a:pPr marL="0" indent="0">
               <a:buNone/>
             </a:pPr>
             <a:r>
@@ -7055,7 +6844,7 @@
             <a:prstDash val="solid"/>
           </a:ln>
           <a:effectLst>
-            <a:outerShdw sx="100000" sy="100000" kx="0" ky="0" algn="bl" rotWithShape="0" blurRad="101600" dist="38100" dir="2700000">
+            <a:outerShdw blurRad="101600" dist="38100" dir="2700000" algn="bl" rotWithShape="0">
               <a:srgbClr val="000000">
                 <a:alpha val="12000"/>
               </a:srgbClr>
@@ -7084,7 +6873,7 @@
           <a:bodyPr wrap="square" lIns="0" tIns="0" rIns="0" bIns="0" rtlCol="0" anchor="ctr"/>
           <a:lstStyle/>
           <a:p>
-            <a:pPr indent="0" marL="0">
+            <a:pPr marL="0" indent="0">
               <a:buNone/>
             </a:pPr>
             <a:r>
@@ -7120,7 +6909,7 @@
           <a:bodyPr wrap="square" lIns="0" tIns="0" rIns="0" bIns="0" rtlCol="0" anchor="ctr"/>
           <a:lstStyle/>
           <a:p>
-            <a:pPr indent="0" marL="0">
+            <a:pPr marL="0" indent="0">
               <a:buNone/>
             </a:pPr>
             <a:r>
@@ -7134,7 +6923,7 @@
             <a:endParaRPr lang="en-US" sz="1100" dirty="0"/>
           </a:p>
           <a:p>
-            <a:pPr indent="0" marL="0">
+            <a:pPr marL="0" indent="0">
               <a:buNone/>
             </a:pPr>
             <a:r>
@@ -7175,7 +6964,7 @@
             <a:prstDash val="solid"/>
           </a:ln>
           <a:effectLst>
-            <a:outerShdw sx="100000" sy="100000" kx="0" ky="0" algn="bl" rotWithShape="0" blurRad="101600" dist="38100" dir="2700000">
+            <a:outerShdw blurRad="101600" dist="38100" dir="2700000" algn="bl" rotWithShape="0">
               <a:srgbClr val="000000">
                 <a:alpha val="12000"/>
               </a:srgbClr>
@@ -7204,7 +6993,7 @@
           <a:bodyPr wrap="square" lIns="0" tIns="0" rIns="0" bIns="0" rtlCol="0" anchor="ctr"/>
           <a:lstStyle/>
           <a:p>
-            <a:pPr indent="0" marL="0">
+            <a:pPr marL="0" indent="0">
               <a:buNone/>
             </a:pPr>
             <a:r>
@@ -7240,7 +7029,7 @@
           <a:bodyPr wrap="square" lIns="0" tIns="0" rIns="0" bIns="0" rtlCol="0" anchor="ctr"/>
           <a:lstStyle/>
           <a:p>
-            <a:pPr indent="0" marL="0">
+            <a:pPr marL="0" indent="0">
               <a:buNone/>
             </a:pPr>
             <a:r>
@@ -7254,7 +7043,7 @@
             <a:endParaRPr lang="en-US" sz="1100" dirty="0"/>
           </a:p>
           <a:p>
-            <a:pPr indent="0" marL="0">
+            <a:pPr marL="0" indent="0">
               <a:buNone/>
             </a:pPr>
             <a:r>
@@ -7285,6 +7074,7 @@
         <a:solidFill>
           <a:srgbClr val="FFFFFF"/>
         </a:solidFill>
+        <a:effectLst/>
       </p:bgPr>
     </p:bg>
     <p:spTree>
@@ -7322,7 +7112,7 @@
           <a:bodyPr wrap="square" rtlCol="0" anchor="ctr"/>
           <a:lstStyle/>
           <a:p>
-            <a:pPr indent="0" marL="0">
+            <a:pPr marL="0" indent="0">
               <a:buNone/>
             </a:pPr>
             <a:r>
@@ -7358,7 +7148,7 @@
           <a:bodyPr wrap="square" rtlCol="0" anchor="ctr"/>
           <a:lstStyle/>
           <a:p>
-            <a:pPr indent="0" marL="0">
+            <a:pPr marL="0" indent="0">
               <a:buNone/>
             </a:pPr>
             <a:r>
@@ -7419,7 +7209,7 @@
           <a:bodyPr wrap="square" lIns="0" tIns="0" rIns="0" bIns="0" rtlCol="0" anchor="ctr"/>
           <a:lstStyle/>
           <a:p>
-            <a:pPr indent="0" marL="0">
+            <a:pPr marL="0" indent="0">
               <a:buNone/>
             </a:pPr>
             <a:r>
@@ -7455,7 +7245,7 @@
           <a:bodyPr wrap="square" lIns="0" tIns="0" rIns="0" bIns="0" rtlCol="0" anchor="ctr"/>
           <a:lstStyle/>
           <a:p>
-            <a:pPr algn="ctr" indent="0" marL="0">
+            <a:pPr marL="0" indent="0" algn="ctr">
               <a:buNone/>
             </a:pPr>
             <a:r>
@@ -7491,7 +7281,7 @@
           <a:bodyPr wrap="square" lIns="0" tIns="0" rIns="0" bIns="0" rtlCol="0" anchor="ctr"/>
           <a:lstStyle/>
           <a:p>
-            <a:pPr algn="ctr" indent="0" marL="0">
+            <a:pPr marL="0" indent="0" algn="ctr">
               <a:buNone/>
             </a:pPr>
             <a:r>
@@ -7552,7 +7342,7 @@
           <a:bodyPr wrap="square" lIns="0" tIns="0" rIns="0" bIns="0" rtlCol="0" anchor="ctr"/>
           <a:lstStyle/>
           <a:p>
-            <a:pPr indent="0" marL="0">
+            <a:pPr marL="0" indent="0">
               <a:buNone/>
             </a:pPr>
             <a:r>
@@ -7588,7 +7378,7 @@
           <a:bodyPr wrap="square" lIns="0" tIns="0" rIns="0" bIns="0" rtlCol="0" anchor="ctr"/>
           <a:lstStyle/>
           <a:p>
-            <a:pPr algn="ctr" indent="0" marL="0">
+            <a:pPr marL="0" indent="0" algn="ctr">
               <a:buNone/>
             </a:pPr>
             <a:r>
@@ -7624,7 +7414,7 @@
           <a:bodyPr wrap="square" lIns="0" tIns="0" rIns="0" bIns="0" rtlCol="0" anchor="ctr"/>
           <a:lstStyle/>
           <a:p>
-            <a:pPr algn="ctr" indent="0" marL="0">
+            <a:pPr marL="0" indent="0" algn="ctr">
               <a:buNone/>
             </a:pPr>
             <a:r>
@@ -7685,7 +7475,7 @@
           <a:bodyPr wrap="square" lIns="0" tIns="0" rIns="0" bIns="0" rtlCol="0" anchor="ctr"/>
           <a:lstStyle/>
           <a:p>
-            <a:pPr indent="0" marL="0">
+            <a:pPr marL="0" indent="0">
               <a:buNone/>
             </a:pPr>
             <a:r>
@@ -7721,7 +7511,7 @@
           <a:bodyPr wrap="square" lIns="0" tIns="0" rIns="0" bIns="0" rtlCol="0" anchor="ctr"/>
           <a:lstStyle/>
           <a:p>
-            <a:pPr algn="ctr" indent="0" marL="0">
+            <a:pPr marL="0" indent="0" algn="ctr">
               <a:buNone/>
             </a:pPr>
             <a:r>
@@ -7757,7 +7547,7 @@
           <a:bodyPr wrap="square" lIns="0" tIns="0" rIns="0" bIns="0" rtlCol="0" anchor="ctr"/>
           <a:lstStyle/>
           <a:p>
-            <a:pPr algn="ctr" indent="0" marL="0">
+            <a:pPr marL="0" indent="0" algn="ctr">
               <a:buNone/>
             </a:pPr>
             <a:r>
@@ -7818,7 +7608,7 @@
           <a:bodyPr wrap="square" lIns="0" tIns="0" rIns="0" bIns="0" rtlCol="0" anchor="ctr"/>
           <a:lstStyle/>
           <a:p>
-            <a:pPr indent="0" marL="0">
+            <a:pPr marL="0" indent="0">
               <a:buNone/>
             </a:pPr>
             <a:r>
@@ -7854,7 +7644,7 @@
           <a:bodyPr wrap="square" lIns="0" tIns="0" rIns="0" bIns="0" rtlCol="0" anchor="ctr"/>
           <a:lstStyle/>
           <a:p>
-            <a:pPr algn="ctr" indent="0" marL="0">
+            <a:pPr marL="0" indent="0" algn="ctr">
               <a:buNone/>
             </a:pPr>
             <a:r>
@@ -7890,7 +7680,7 @@
           <a:bodyPr wrap="square" lIns="0" tIns="0" rIns="0" bIns="0" rtlCol="0" anchor="ctr"/>
           <a:lstStyle/>
           <a:p>
-            <a:pPr algn="ctr" indent="0" marL="0">
+            <a:pPr marL="0" indent="0" algn="ctr">
               <a:buNone/>
             </a:pPr>
             <a:r>
@@ -7951,7 +7741,7 @@
           <a:bodyPr wrap="square" lIns="0" tIns="0" rIns="0" bIns="0" rtlCol="0" anchor="ctr"/>
           <a:lstStyle/>
           <a:p>
-            <a:pPr indent="0" marL="0">
+            <a:pPr marL="0" indent="0">
               <a:buNone/>
             </a:pPr>
             <a:r>
@@ -7987,7 +7777,7 @@
           <a:bodyPr wrap="square" lIns="0" tIns="0" rIns="0" bIns="0" rtlCol="0" anchor="ctr"/>
           <a:lstStyle/>
           <a:p>
-            <a:pPr algn="ctr" indent="0" marL="0">
+            <a:pPr marL="0" indent="0" algn="ctr">
               <a:buNone/>
             </a:pPr>
             <a:r>
@@ -8023,7 +7813,7 @@
           <a:bodyPr wrap="square" lIns="0" tIns="0" rIns="0" bIns="0" rtlCol="0" anchor="ctr"/>
           <a:lstStyle/>
           <a:p>
-            <a:pPr algn="ctr" indent="0" marL="0">
+            <a:pPr marL="0" indent="0" algn="ctr">
               <a:buNone/>
             </a:pPr>
             <a:r>
@@ -8084,7 +7874,7 @@
           <a:bodyPr wrap="square" lIns="0" tIns="0" rIns="0" bIns="0" rtlCol="0" anchor="ctr"/>
           <a:lstStyle/>
           <a:p>
-            <a:pPr indent="0" marL="0">
+            <a:pPr marL="0" indent="0">
               <a:buNone/>
             </a:pPr>
             <a:r>
@@ -8120,7 +7910,7 @@
           <a:bodyPr wrap="square" lIns="0" tIns="0" rIns="0" bIns="0" rtlCol="0" anchor="ctr"/>
           <a:lstStyle/>
           <a:p>
-            <a:pPr algn="ctr" indent="0" marL="0">
+            <a:pPr marL="0" indent="0" algn="ctr">
               <a:buNone/>
             </a:pPr>
             <a:r>
@@ -8156,7 +7946,7 @@
           <a:bodyPr wrap="square" lIns="0" tIns="0" rIns="0" bIns="0" rtlCol="0" anchor="ctr"/>
           <a:lstStyle/>
           <a:p>
-            <a:pPr algn="ctr" indent="0" marL="0">
+            <a:pPr marL="0" indent="0" algn="ctr">
               <a:buNone/>
             </a:pPr>
             <a:r>
@@ -8217,7 +8007,7 @@
           <a:bodyPr wrap="square" lIns="0" tIns="0" rIns="0" bIns="0" rtlCol="0" anchor="ctr"/>
           <a:lstStyle/>
           <a:p>
-            <a:pPr indent="0" marL="0">
+            <a:pPr marL="0" indent="0">
               <a:buNone/>
             </a:pPr>
             <a:r>
@@ -8253,7 +8043,7 @@
           <a:bodyPr wrap="square" lIns="0" tIns="0" rIns="0" bIns="0" rtlCol="0" anchor="ctr"/>
           <a:lstStyle/>
           <a:p>
-            <a:pPr algn="ctr" indent="0" marL="0">
+            <a:pPr marL="0" indent="0" algn="ctr">
               <a:buNone/>
             </a:pPr>
             <a:r>
@@ -8289,7 +8079,7 @@
           <a:bodyPr wrap="square" lIns="0" tIns="0" rIns="0" bIns="0" rtlCol="0" anchor="ctr"/>
           <a:lstStyle/>
           <a:p>
-            <a:pPr algn="ctr" indent="0" marL="0">
+            <a:pPr marL="0" indent="0" algn="ctr">
               <a:buNone/>
             </a:pPr>
             <a:r>
@@ -8350,7 +8140,7 @@
           <a:bodyPr wrap="square" lIns="0" tIns="0" rIns="0" bIns="0" rtlCol="0" anchor="ctr"/>
           <a:lstStyle/>
           <a:p>
-            <a:pPr indent="0" marL="0">
+            <a:pPr marL="0" indent="0">
               <a:buNone/>
             </a:pPr>
             <a:r>
@@ -8386,7 +8176,7 @@
           <a:bodyPr wrap="square" lIns="0" tIns="0" rIns="0" bIns="0" rtlCol="0" anchor="ctr"/>
           <a:lstStyle/>
           <a:p>
-            <a:pPr algn="ctr" indent="0" marL="0">
+            <a:pPr marL="0" indent="0" algn="ctr">
               <a:buNone/>
             </a:pPr>
             <a:r>
@@ -8422,7 +8212,7 @@
           <a:bodyPr wrap="square" lIns="0" tIns="0" rIns="0" bIns="0" rtlCol="0" anchor="ctr"/>
           <a:lstStyle/>
           <a:p>
-            <a:pPr algn="ctr" indent="0" marL="0">
+            <a:pPr marL="0" indent="0" algn="ctr">
               <a:buNone/>
             </a:pPr>
             <a:r>
@@ -8453,6 +8243,7 @@
         <a:solidFill>
           <a:srgbClr val="0A1628"/>
         </a:solidFill>
+        <a:effectLst/>
       </p:bgPr>
     </p:bg>
     <p:spTree>
@@ -8519,7 +8310,7 @@
           <a:bodyPr wrap="square" rtlCol="0" anchor="ctr"/>
           <a:lstStyle/>
           <a:p>
-            <a:pPr indent="0" marL="0">
+            <a:pPr marL="0" indent="0">
               <a:buNone/>
             </a:pPr>
             <a:r>
@@ -8555,7 +8346,7 @@
           <a:bodyPr wrap="square" rtlCol="0" anchor="ctr"/>
           <a:lstStyle/>
           <a:p>
-            <a:pPr indent="0" marL="0">
+            <a:pPr marL="0" indent="0">
               <a:buNone/>
             </a:pPr>
             <a:r>
@@ -8618,7 +8409,7 @@
           <a:bodyPr wrap="square" lIns="0" tIns="0" rIns="0" bIns="0" rtlCol="0" anchor="ctr"/>
           <a:lstStyle/>
           <a:p>
-            <a:pPr indent="0" marL="0">
+            <a:pPr marL="0" indent="0">
               <a:buNone/>
             </a:pPr>
             <a:r>
@@ -8654,7 +8445,7 @@
           <a:bodyPr wrap="square" lIns="0" tIns="0" rIns="0" bIns="0" rtlCol="0" anchor="ctr"/>
           <a:lstStyle/>
           <a:p>
-            <a:pPr indent="0" marL="0">
+            <a:pPr marL="0" indent="0">
               <a:buNone/>
             </a:pPr>
             <a:r>
@@ -8717,7 +8508,7 @@
           <a:bodyPr wrap="square" lIns="0" tIns="0" rIns="0" bIns="0" rtlCol="0" anchor="ctr"/>
           <a:lstStyle/>
           <a:p>
-            <a:pPr indent="0" marL="0">
+            <a:pPr marL="0" indent="0">
               <a:buNone/>
             </a:pPr>
             <a:r>
@@ -8753,7 +8544,7 @@
           <a:bodyPr wrap="square" lIns="0" tIns="0" rIns="0" bIns="0" rtlCol="0" anchor="ctr"/>
           <a:lstStyle/>
           <a:p>
-            <a:pPr indent="0" marL="0">
+            <a:pPr marL="0" indent="0">
               <a:buNone/>
             </a:pPr>
             <a:r>
@@ -8816,7 +8607,7 @@
           <a:bodyPr wrap="square" lIns="0" tIns="0" rIns="0" bIns="0" rtlCol="0" anchor="ctr"/>
           <a:lstStyle/>
           <a:p>
-            <a:pPr indent="0" marL="0">
+            <a:pPr marL="0" indent="0">
               <a:buNone/>
             </a:pPr>
             <a:r>
@@ -8852,7 +8643,7 @@
           <a:bodyPr wrap="square" lIns="0" tIns="0" rIns="0" bIns="0" rtlCol="0" anchor="ctr"/>
           <a:lstStyle/>
           <a:p>
-            <a:pPr indent="0" marL="0">
+            <a:pPr marL="0" indent="0">
               <a:buNone/>
             </a:pPr>
             <a:r>
@@ -8888,7 +8679,7 @@
           <a:bodyPr wrap="square" rtlCol="0" anchor="ctr"/>
           <a:lstStyle/>
           <a:p>
-            <a:pPr algn="ctr" indent="0" marL="0">
+            <a:pPr marL="0" indent="0" algn="ctr">
               <a:buNone/>
             </a:pPr>
             <a:r>
@@ -8919,6 +8710,7 @@
         <a:solidFill>
           <a:srgbClr val="FFFFFF"/>
         </a:solidFill>
+        <a:effectLst/>
       </p:bgPr>
     </p:bg>
     <p:spTree>
@@ -8956,7 +8748,7 @@
           <a:bodyPr wrap="square" rtlCol="0" anchor="ctr"/>
           <a:lstStyle/>
           <a:p>
-            <a:pPr indent="0" marL="0">
+            <a:pPr marL="0" indent="0">
               <a:buNone/>
             </a:pPr>
             <a:r>
@@ -8992,7 +8784,7 @@
           <a:bodyPr wrap="square" rtlCol="0" anchor="ctr"/>
           <a:lstStyle/>
           <a:p>
-            <a:pPr indent="0" marL="0">
+            <a:pPr marL="0" indent="0">
               <a:buNone/>
             </a:pPr>
             <a:r>
@@ -9033,7 +8825,7 @@
             <a:prstDash val="solid"/>
           </a:ln>
           <a:effectLst>
-            <a:outerShdw sx="100000" sy="100000" kx="0" ky="0" algn="bl" rotWithShape="0" blurRad="101600" dist="38100" dir="2700000">
+            <a:outerShdw blurRad="101600" dist="38100" dir="2700000" algn="bl" rotWithShape="0">
               <a:srgbClr val="000000">
                 <a:alpha val="12000"/>
               </a:srgbClr>
@@ -9114,7 +8906,7 @@
           <a:bodyPr wrap="square" lIns="0" tIns="0" rIns="0" bIns="0" rtlCol="0" anchor="ctr"/>
           <a:lstStyle/>
           <a:p>
-            <a:pPr algn="ctr" indent="0" marL="0">
+            <a:pPr marL="0" indent="0" algn="ctr">
               <a:buNone/>
             </a:pPr>
             <a:r>
@@ -9177,7 +8969,7 @@
           <a:bodyPr wrap="square" lIns="0" tIns="0" rIns="0" bIns="0" rtlCol="0" anchor="ctr"/>
           <a:lstStyle/>
           <a:p>
-            <a:pPr indent="0" marL="0">
+            <a:pPr marL="0" indent="0">
               <a:buNone/>
             </a:pPr>
             <a:r>
@@ -9240,7 +9032,7 @@
           <a:bodyPr wrap="square" lIns="0" tIns="0" rIns="0" bIns="0" rtlCol="0" anchor="ctr"/>
           <a:lstStyle/>
           <a:p>
-            <a:pPr indent="0" marL="0">
+            <a:pPr marL="0" indent="0">
               <a:buNone/>
             </a:pPr>
             <a:r>
@@ -9281,7 +9073,7 @@
             <a:prstDash val="solid"/>
           </a:ln>
           <a:effectLst>
-            <a:outerShdw sx="100000" sy="100000" kx="0" ky="0" algn="bl" rotWithShape="0" blurRad="101600" dist="38100" dir="2700000">
+            <a:outerShdw blurRad="101600" dist="38100" dir="2700000" algn="bl" rotWithShape="0">
               <a:srgbClr val="000000">
                 <a:alpha val="12000"/>
               </a:srgbClr>
@@ -9362,7 +9154,7 @@
           <a:bodyPr wrap="square" lIns="0" tIns="0" rIns="0" bIns="0" rtlCol="0" anchor="ctr"/>
           <a:lstStyle/>
           <a:p>
-            <a:pPr algn="ctr" indent="0" marL="0">
+            <a:pPr marL="0" indent="0" algn="ctr">
               <a:buNone/>
             </a:pPr>
             <a:r>
@@ -9425,7 +9217,7 @@
           <a:bodyPr wrap="square" lIns="0" tIns="0" rIns="0" bIns="0" rtlCol="0" anchor="ctr"/>
           <a:lstStyle/>
           <a:p>
-            <a:pPr indent="0" marL="0">
+            <a:pPr marL="0" indent="0">
               <a:buNone/>
             </a:pPr>
             <a:r>
@@ -9488,7 +9280,7 @@
           <a:bodyPr wrap="square" lIns="0" tIns="0" rIns="0" bIns="0" rtlCol="0" anchor="ctr"/>
           <a:lstStyle/>
           <a:p>
-            <a:pPr indent="0" marL="0">
+            <a:pPr marL="0" indent="0">
               <a:buNone/>
             </a:pPr>
             <a:r>
@@ -9551,7 +9343,7 @@
           <a:bodyPr wrap="square" lIns="0" tIns="0" rIns="0" bIns="0" rtlCol="0" anchor="ctr"/>
           <a:lstStyle/>
           <a:p>
-            <a:pPr indent="0" marL="0">
+            <a:pPr marL="0" indent="0">
               <a:buNone/>
             </a:pPr>
             <a:r>
@@ -9614,7 +9406,7 @@
           <a:bodyPr wrap="square" lIns="0" tIns="0" rIns="0" bIns="0" rtlCol="0" anchor="ctr"/>
           <a:lstStyle/>
           <a:p>
-            <a:pPr indent="0" marL="0">
+            <a:pPr marL="0" indent="0">
               <a:buNone/>
             </a:pPr>
             <a:r>
@@ -9677,7 +9469,7 @@
           <a:bodyPr wrap="square" lIns="0" tIns="0" rIns="0" bIns="0" rtlCol="0" anchor="ctr"/>
           <a:lstStyle/>
           <a:p>
-            <a:pPr indent="0" marL="0">
+            <a:pPr marL="0" indent="0">
               <a:buNone/>
             </a:pPr>
             <a:r>
@@ -9740,7 +9532,7 @@
           <a:bodyPr wrap="square" lIns="0" tIns="0" rIns="0" bIns="0" rtlCol="0" anchor="ctr"/>
           <a:lstStyle/>
           <a:p>
-            <a:pPr indent="0" marL="0">
+            <a:pPr marL="0" indent="0">
               <a:buNone/>
             </a:pPr>
             <a:r>
@@ -9781,7 +9573,7 @@
             <a:prstDash val="solid"/>
           </a:ln>
           <a:effectLst>
-            <a:outerShdw sx="100000" sy="100000" kx="0" ky="0" algn="bl" rotWithShape="0" blurRad="101600" dist="38100" dir="2700000">
+            <a:outerShdw blurRad="101600" dist="38100" dir="2700000" algn="bl" rotWithShape="0">
               <a:srgbClr val="000000">
                 <a:alpha val="12000"/>
               </a:srgbClr>
@@ -9862,7 +9654,7 @@
           <a:bodyPr wrap="square" lIns="0" tIns="0" rIns="0" bIns="0" rtlCol="0" anchor="ctr"/>
           <a:lstStyle/>
           <a:p>
-            <a:pPr algn="ctr" indent="0" marL="0">
+            <a:pPr marL="0" indent="0" algn="ctr">
               <a:buNone/>
             </a:pPr>
             <a:r>
@@ -9925,7 +9717,7 @@
           <a:bodyPr wrap="square" lIns="0" tIns="0" rIns="0" bIns="0" rtlCol="0" anchor="ctr"/>
           <a:lstStyle/>
           <a:p>
-            <a:pPr indent="0" marL="0">
+            <a:pPr marL="0" indent="0">
               <a:buNone/>
             </a:pPr>
             <a:r>
@@ -9988,7 +9780,7 @@
           <a:bodyPr wrap="square" lIns="0" tIns="0" rIns="0" bIns="0" rtlCol="0" anchor="ctr"/>
           <a:lstStyle/>
           <a:p>
-            <a:pPr indent="0" marL="0">
+            <a:pPr marL="0" indent="0">
               <a:buNone/>
             </a:pPr>
             <a:r>
@@ -10051,7 +9843,7 @@
           <a:bodyPr wrap="square" lIns="0" tIns="0" rIns="0" bIns="0" rtlCol="0" anchor="ctr"/>
           <a:lstStyle/>
           <a:p>
-            <a:pPr indent="0" marL="0">
+            <a:pPr marL="0" indent="0">
               <a:buNone/>
             </a:pPr>
             <a:r>
@@ -10114,7 +9906,7 @@
           <a:bodyPr wrap="square" lIns="0" tIns="0" rIns="0" bIns="0" rtlCol="0" anchor="ctr"/>
           <a:lstStyle/>
           <a:p>
-            <a:pPr indent="0" marL="0">
+            <a:pPr marL="0" indent="0">
               <a:buNone/>
             </a:pPr>
             <a:r>
@@ -10177,7 +9969,7 @@
           <a:bodyPr wrap="square" lIns="0" tIns="0" rIns="0" bIns="0" rtlCol="0" anchor="ctr"/>
           <a:lstStyle/>
           <a:p>
-            <a:pPr indent="0" marL="0">
+            <a:pPr marL="0" indent="0">
               <a:buNone/>
             </a:pPr>
             <a:r>
@@ -10208,6 +10000,7 @@
         <a:solidFill>
           <a:srgbClr val="FFFFFF"/>
         </a:solidFill>
+        <a:effectLst/>
       </p:bgPr>
     </p:bg>
     <p:spTree>
@@ -10245,7 +10038,7 @@
           <a:bodyPr wrap="square" rtlCol="0" anchor="ctr"/>
           <a:lstStyle/>
           <a:p>
-            <a:pPr indent="0" marL="0">
+            <a:pPr marL="0" indent="0">
               <a:buNone/>
             </a:pPr>
             <a:r>
@@ -10281,7 +10074,7 @@
           <a:bodyPr wrap="square" rtlCol="0" anchor="ctr"/>
           <a:lstStyle/>
           <a:p>
-            <a:pPr indent="0" marL="0">
+            <a:pPr marL="0" indent="0">
               <a:buNone/>
             </a:pPr>
             <a:r>
@@ -10396,7 +10189,7 @@
           <a:bodyPr wrap="square" lIns="0" tIns="0" rIns="0" bIns="0" rtlCol="0" anchor="ctr"/>
           <a:lstStyle/>
           <a:p>
-            <a:pPr algn="ctr" indent="0" marL="0">
+            <a:pPr marL="0" indent="0" algn="ctr">
               <a:buNone/>
             </a:pPr>
             <a:r>
@@ -10432,7 +10225,7 @@
           <a:bodyPr wrap="square" lIns="0" tIns="0" rIns="0" bIns="0" rtlCol="0" anchor="ctr"/>
           <a:lstStyle/>
           <a:p>
-            <a:pPr indent="0" marL="0">
+            <a:pPr marL="0" indent="0">
               <a:buNone/>
             </a:pPr>
             <a:r>
@@ -10468,7 +10261,7 @@
           <a:bodyPr wrap="square" lIns="0" tIns="0" rIns="0" bIns="0" rtlCol="0" anchor="ctr"/>
           <a:lstStyle/>
           <a:p>
-            <a:pPr indent="0" marL="0">
+            <a:pPr marL="0" indent="0">
               <a:buNone/>
             </a:pPr>
             <a:r>
@@ -10583,7 +10376,7 @@
           <a:bodyPr wrap="square" lIns="0" tIns="0" rIns="0" bIns="0" rtlCol="0" anchor="ctr"/>
           <a:lstStyle/>
           <a:p>
-            <a:pPr algn="ctr" indent="0" marL="0">
+            <a:pPr marL="0" indent="0" algn="ctr">
               <a:buNone/>
             </a:pPr>
             <a:r>
@@ -10619,7 +10412,7 @@
           <a:bodyPr wrap="square" lIns="0" tIns="0" rIns="0" bIns="0" rtlCol="0" anchor="ctr"/>
           <a:lstStyle/>
           <a:p>
-            <a:pPr indent="0" marL="0">
+            <a:pPr marL="0" indent="0">
               <a:buNone/>
             </a:pPr>
             <a:r>
@@ -10655,7 +10448,7 @@
           <a:bodyPr wrap="square" lIns="0" tIns="0" rIns="0" bIns="0" rtlCol="0" anchor="ctr"/>
           <a:lstStyle/>
           <a:p>
-            <a:pPr indent="0" marL="0">
+            <a:pPr marL="0" indent="0">
               <a:buNone/>
             </a:pPr>
             <a:r>
@@ -10770,7 +10563,7 @@
           <a:bodyPr wrap="square" lIns="0" tIns="0" rIns="0" bIns="0" rtlCol="0" anchor="ctr"/>
           <a:lstStyle/>
           <a:p>
-            <a:pPr algn="ctr" indent="0" marL="0">
+            <a:pPr marL="0" indent="0" algn="ctr">
               <a:buNone/>
             </a:pPr>
             <a:r>
@@ -10806,7 +10599,7 @@
           <a:bodyPr wrap="square" lIns="0" tIns="0" rIns="0" bIns="0" rtlCol="0" anchor="ctr"/>
           <a:lstStyle/>
           <a:p>
-            <a:pPr indent="0" marL="0">
+            <a:pPr marL="0" indent="0">
               <a:buNone/>
             </a:pPr>
             <a:r>
@@ -10842,7 +10635,7 @@
           <a:bodyPr wrap="square" lIns="0" tIns="0" rIns="0" bIns="0" rtlCol="0" anchor="ctr"/>
           <a:lstStyle/>
           <a:p>
-            <a:pPr indent="0" marL="0">
+            <a:pPr marL="0" indent="0">
               <a:buNone/>
             </a:pPr>
             <a:r>
@@ -10957,7 +10750,7 @@
           <a:bodyPr wrap="square" lIns="0" tIns="0" rIns="0" bIns="0" rtlCol="0" anchor="ctr"/>
           <a:lstStyle/>
           <a:p>
-            <a:pPr algn="ctr" indent="0" marL="0">
+            <a:pPr marL="0" indent="0" algn="ctr">
               <a:buNone/>
             </a:pPr>
             <a:r>
@@ -10993,7 +10786,7 @@
           <a:bodyPr wrap="square" lIns="0" tIns="0" rIns="0" bIns="0" rtlCol="0" anchor="ctr"/>
           <a:lstStyle/>
           <a:p>
-            <a:pPr indent="0" marL="0">
+            <a:pPr marL="0" indent="0">
               <a:buNone/>
             </a:pPr>
             <a:r>
@@ -11029,7 +10822,7 @@
           <a:bodyPr wrap="square" lIns="0" tIns="0" rIns="0" bIns="0" rtlCol="0" anchor="ctr"/>
           <a:lstStyle/>
           <a:p>
-            <a:pPr indent="0" marL="0">
+            <a:pPr marL="0" indent="0">
               <a:buNone/>
             </a:pPr>
             <a:r>
@@ -11144,7 +10937,7 @@
           <a:bodyPr wrap="square" lIns="0" tIns="0" rIns="0" bIns="0" rtlCol="0" anchor="ctr"/>
           <a:lstStyle/>
           <a:p>
-            <a:pPr algn="ctr" indent="0" marL="0">
+            <a:pPr marL="0" indent="0" algn="ctr">
               <a:buNone/>
             </a:pPr>
             <a:r>
@@ -11180,7 +10973,7 @@
           <a:bodyPr wrap="square" lIns="0" tIns="0" rIns="0" bIns="0" rtlCol="0" anchor="ctr"/>
           <a:lstStyle/>
           <a:p>
-            <a:pPr indent="0" marL="0">
+            <a:pPr marL="0" indent="0">
               <a:buNone/>
             </a:pPr>
             <a:r>
@@ -11216,7 +11009,7 @@
           <a:bodyPr wrap="square" lIns="0" tIns="0" rIns="0" bIns="0" rtlCol="0" anchor="ctr"/>
           <a:lstStyle/>
           <a:p>
-            <a:pPr indent="0" marL="0">
+            <a:pPr marL="0" indent="0">
               <a:buNone/>
             </a:pPr>
             <a:r>
@@ -11532,4 +11325,319 @@
     </a:ext>
   </a:extLst>
 </a:theme>
+</file>
+
+<file path=ppt/theme/theme2.xml><?xml version="1.0" encoding="utf-8"?>
+<a:theme xmlns:a="http://schemas.openxmlformats.org/drawingml/2006/main" name="Office Theme">
+  <a:themeElements>
+    <a:clrScheme name="Office">
+      <a:dk1>
+        <a:sysClr val="windowText" lastClr="000000"/>
+      </a:dk1>
+      <a:lt1>
+        <a:sysClr val="window" lastClr="FFFFFF"/>
+      </a:lt1>
+      <a:dk2>
+        <a:srgbClr val="0E2841"/>
+      </a:dk2>
+      <a:lt2>
+        <a:srgbClr val="E8E8E8"/>
+      </a:lt2>
+      <a:accent1>
+        <a:srgbClr val="156082"/>
+      </a:accent1>
+      <a:accent2>
+        <a:srgbClr val="E97132"/>
+      </a:accent2>
+      <a:accent3>
+        <a:srgbClr val="196B24"/>
+      </a:accent3>
+      <a:accent4>
+        <a:srgbClr val="0F9ED5"/>
+      </a:accent4>
+      <a:accent5>
+        <a:srgbClr val="A02B93"/>
+      </a:accent5>
+      <a:accent6>
+        <a:srgbClr val="4EA72E"/>
+      </a:accent6>
+      <a:hlink>
+        <a:srgbClr val="467886"/>
+      </a:hlink>
+      <a:folHlink>
+        <a:srgbClr val="96607D"/>
+      </a:folHlink>
+    </a:clrScheme>
+    <a:fontScheme name="Office">
+      <a:majorFont>
+        <a:latin typeface="Aptos Display" panose="02110004020202020204"/>
+        <a:ea typeface=""/>
+        <a:cs typeface=""/>
+        <a:font script="Jpan" typeface="游ゴシック Light"/>
+        <a:font script="Hang" typeface="맑은 고딕"/>
+        <a:font script="Hans" typeface="等线 Light"/>
+        <a:font script="Hant" typeface="新細明體"/>
+        <a:font script="Arab" typeface="Times New Roman"/>
+        <a:font script="Hebr" typeface="Times New Roman"/>
+        <a:font script="Thai" typeface="Angsana New"/>
+        <a:font script="Ethi" typeface="Nyala"/>
+        <a:font script="Beng" typeface="Vrinda"/>
+        <a:font script="Gujr" typeface="Shruti"/>
+        <a:font script="Khmr" typeface="MoolBoran"/>
+        <a:font script="Knda" typeface="Tunga"/>
+        <a:font script="Guru" typeface="Raavi"/>
+        <a:font script="Cans" typeface="Euphemia"/>
+        <a:font script="Cher" typeface="Plantagenet Cherokee"/>
+        <a:font script="Yiii" typeface="Microsoft Yi Baiti"/>
+        <a:font script="Tibt" typeface="Microsoft Himalaya"/>
+        <a:font script="Thaa" typeface="MV Boli"/>
+        <a:font script="Deva" typeface="Mangal"/>
+        <a:font script="Telu" typeface="Gautami"/>
+        <a:font script="Taml" typeface="Latha"/>
+        <a:font script="Syrc" typeface="Estrangelo Edessa"/>
+        <a:font script="Orya" typeface="Kalinga"/>
+        <a:font script="Mlym" typeface="Kartika"/>
+        <a:font script="Laoo" typeface="DokChampa"/>
+        <a:font script="Sinh" typeface="Iskoola Pota"/>
+        <a:font script="Mong" typeface="Mongolian Baiti"/>
+        <a:font script="Viet" typeface="Times New Roman"/>
+        <a:font script="Uigh" typeface="Microsoft Uighur"/>
+        <a:font script="Geor" typeface="Sylfaen"/>
+        <a:font script="Armn" typeface="Arial"/>
+        <a:font script="Bugi" typeface="Leelawadee UI"/>
+        <a:font script="Bopo" typeface="Microsoft JhengHei"/>
+        <a:font script="Java" typeface="Javanese Text"/>
+        <a:font script="Lisu" typeface="Segoe UI"/>
+        <a:font script="Mymr" typeface="Myanmar Text"/>
+        <a:font script="Nkoo" typeface="Ebrima"/>
+        <a:font script="Olck" typeface="Nirmala UI"/>
+        <a:font script="Osma" typeface="Ebrima"/>
+        <a:font script="Phag" typeface="Phagspa"/>
+        <a:font script="Syrn" typeface="Estrangelo Edessa"/>
+        <a:font script="Syrj" typeface="Estrangelo Edessa"/>
+        <a:font script="Syre" typeface="Estrangelo Edessa"/>
+        <a:font script="Sora" typeface="Nirmala UI"/>
+        <a:font script="Tale" typeface="Microsoft Tai Le"/>
+        <a:font script="Talu" typeface="Microsoft New Tai Lue"/>
+        <a:font script="Tfng" typeface="Ebrima"/>
+      </a:majorFont>
+      <a:minorFont>
+        <a:latin typeface="Aptos" panose="02110004020202020204"/>
+        <a:ea typeface=""/>
+        <a:cs typeface=""/>
+        <a:font script="Jpan" typeface="游ゴシック"/>
+        <a:font script="Hang" typeface="맑은 고딕"/>
+        <a:font script="Hans" typeface="等线"/>
+        <a:font script="Hant" typeface="新細明體"/>
+        <a:font script="Arab" typeface="Arial"/>
+        <a:font script="Hebr" typeface="Arial"/>
+        <a:font script="Thai" typeface="Cordia New"/>
+        <a:font script="Ethi" typeface="Nyala"/>
+        <a:font script="Beng" typeface="Vrinda"/>
+        <a:font script="Gujr" typeface="Shruti"/>
+        <a:font script="Khmr" typeface="DaunPenh"/>
+        <a:font script="Knda" typeface="Tunga"/>
+        <a:font script="Guru" typeface="Raavi"/>
+        <a:font script="Cans" typeface="Euphemia"/>
+        <a:font script="Cher" typeface="Plantagenet Cherokee"/>
+        <a:font script="Yiii" typeface="Microsoft Yi Baiti"/>
+        <a:font script="Tibt" typeface="Microsoft Himalaya"/>
+        <a:font script="Thaa" typeface="MV Boli"/>
+        <a:font script="Deva" typeface="Mangal"/>
+        <a:font script="Telu" typeface="Gautami"/>
+        <a:font script="Taml" typeface="Latha"/>
+        <a:font script="Syrc" typeface="Estrangelo Edessa"/>
+        <a:font script="Orya" typeface="Kalinga"/>
+        <a:font script="Mlym" typeface="Kartika"/>
+        <a:font script="Laoo" typeface="DokChampa"/>
+        <a:font script="Sinh" typeface="Iskoola Pota"/>
+        <a:font script="Mong" typeface="Mongolian Baiti"/>
+        <a:font script="Viet" typeface="Arial"/>
+        <a:font script="Uigh" typeface="Microsoft Uighur"/>
+        <a:font script="Geor" typeface="Sylfaen"/>
+        <a:font script="Armn" typeface="Arial"/>
+        <a:font script="Bugi" typeface="Leelawadee UI"/>
+        <a:font script="Bopo" typeface="Microsoft JhengHei"/>
+        <a:font script="Java" typeface="Javanese Text"/>
+        <a:font script="Lisu" typeface="Segoe UI"/>
+        <a:font script="Mymr" typeface="Myanmar Text"/>
+        <a:font script="Nkoo" typeface="Ebrima"/>
+        <a:font script="Olck" typeface="Nirmala UI"/>
+        <a:font script="Osma" typeface="Ebrima"/>
+        <a:font script="Phag" typeface="Phagspa"/>
+        <a:font script="Syrn" typeface="Estrangelo Edessa"/>
+        <a:font script="Syrj" typeface="Estrangelo Edessa"/>
+        <a:font script="Syre" typeface="Estrangelo Edessa"/>
+        <a:font script="Sora" typeface="Nirmala UI"/>
+        <a:font script="Tale" typeface="Microsoft Tai Le"/>
+        <a:font script="Talu" typeface="Microsoft New Tai Lue"/>
+        <a:font script="Tfng" typeface="Ebrima"/>
+      </a:minorFont>
+    </a:fontScheme>
+    <a:fmtScheme name="Office">
+      <a:fillStyleLst>
+        <a:solidFill>
+          <a:schemeClr val="phClr"/>
+        </a:solidFill>
+        <a:gradFill rotWithShape="1">
+          <a:gsLst>
+            <a:gs pos="0">
+              <a:schemeClr val="phClr">
+                <a:lumMod val="110000"/>
+                <a:satMod val="105000"/>
+                <a:tint val="67000"/>
+              </a:schemeClr>
+            </a:gs>
+            <a:gs pos="50000">
+              <a:schemeClr val="phClr">
+                <a:lumMod val="105000"/>
+                <a:satMod val="103000"/>
+                <a:tint val="73000"/>
+              </a:schemeClr>
+            </a:gs>
+            <a:gs pos="100000">
+              <a:schemeClr val="phClr">
+                <a:lumMod val="105000"/>
+                <a:satMod val="109000"/>
+                <a:tint val="81000"/>
+              </a:schemeClr>
+            </a:gs>
+          </a:gsLst>
+          <a:lin ang="5400000" scaled="0"/>
+        </a:gradFill>
+        <a:gradFill rotWithShape="1">
+          <a:gsLst>
+            <a:gs pos="0">
+              <a:schemeClr val="phClr">
+                <a:satMod val="103000"/>
+                <a:lumMod val="102000"/>
+                <a:tint val="94000"/>
+              </a:schemeClr>
+            </a:gs>
+            <a:gs pos="50000">
+              <a:schemeClr val="phClr">
+                <a:satMod val="110000"/>
+                <a:lumMod val="100000"/>
+                <a:shade val="100000"/>
+              </a:schemeClr>
+            </a:gs>
+            <a:gs pos="100000">
+              <a:schemeClr val="phClr">
+                <a:lumMod val="99000"/>
+                <a:satMod val="120000"/>
+                <a:shade val="78000"/>
+              </a:schemeClr>
+            </a:gs>
+          </a:gsLst>
+          <a:lin ang="5400000" scaled="0"/>
+        </a:gradFill>
+      </a:fillStyleLst>
+      <a:lnStyleLst>
+        <a:ln w="12700" cap="flat" cmpd="sng" algn="ctr">
+          <a:solidFill>
+            <a:schemeClr val="phClr"/>
+          </a:solidFill>
+          <a:prstDash val="solid"/>
+          <a:miter lim="800000"/>
+        </a:ln>
+        <a:ln w="19050" cap="flat" cmpd="sng" algn="ctr">
+          <a:solidFill>
+            <a:schemeClr val="phClr"/>
+          </a:solidFill>
+          <a:prstDash val="solid"/>
+          <a:miter lim="800000"/>
+        </a:ln>
+        <a:ln w="25400" cap="flat" cmpd="sng" algn="ctr">
+          <a:solidFill>
+            <a:schemeClr val="phClr"/>
+          </a:solidFill>
+          <a:prstDash val="solid"/>
+          <a:miter lim="800000"/>
+        </a:ln>
+      </a:lnStyleLst>
+      <a:effectStyleLst>
+        <a:effectStyle>
+          <a:effectLst/>
+        </a:effectStyle>
+        <a:effectStyle>
+          <a:effectLst/>
+        </a:effectStyle>
+        <a:effectStyle>
+          <a:effectLst>
+            <a:outerShdw blurRad="57150" dist="19050" dir="5400000" algn="ctr" rotWithShape="0">
+              <a:srgbClr val="000000">
+                <a:alpha val="63000"/>
+              </a:srgbClr>
+            </a:outerShdw>
+          </a:effectLst>
+        </a:effectStyle>
+      </a:effectStyleLst>
+      <a:bgFillStyleLst>
+        <a:solidFill>
+          <a:schemeClr val="phClr"/>
+        </a:solidFill>
+        <a:solidFill>
+          <a:schemeClr val="phClr">
+            <a:tint val="95000"/>
+            <a:satMod val="170000"/>
+          </a:schemeClr>
+        </a:solidFill>
+        <a:gradFill rotWithShape="1">
+          <a:gsLst>
+            <a:gs pos="0">
+              <a:schemeClr val="phClr">
+                <a:tint val="93000"/>
+                <a:satMod val="150000"/>
+                <a:shade val="98000"/>
+                <a:lumMod val="102000"/>
+              </a:schemeClr>
+            </a:gs>
+            <a:gs pos="50000">
+              <a:schemeClr val="phClr">
+                <a:tint val="98000"/>
+                <a:satMod val="130000"/>
+                <a:shade val="90000"/>
+                <a:lumMod val="103000"/>
+              </a:schemeClr>
+            </a:gs>
+            <a:gs pos="100000">
+              <a:schemeClr val="phClr">
+                <a:shade val="63000"/>
+                <a:satMod val="120000"/>
+              </a:schemeClr>
+            </a:gs>
+          </a:gsLst>
+          <a:lin ang="5400000" scaled="0"/>
+        </a:gradFill>
+      </a:bgFillStyleLst>
+    </a:fmtScheme>
+  </a:themeElements>
+  <a:objectDefaults>
+    <a:lnDef>
+      <a:spPr/>
+      <a:bodyPr/>
+      <a:lstStyle/>
+      <a:style>
+        <a:lnRef idx="2">
+          <a:schemeClr val="accent1"/>
+        </a:lnRef>
+        <a:fillRef idx="0">
+          <a:schemeClr val="accent1"/>
+        </a:fillRef>
+        <a:effectRef idx="1">
+          <a:schemeClr val="accent1"/>
+        </a:effectRef>
+        <a:fontRef idx="minor">
+          <a:schemeClr val="tx1"/>
+        </a:fontRef>
+      </a:style>
+    </a:lnDef>
+  </a:objectDefaults>
+  <a:extraClrSchemeLst/>
+  <a:extLst>
+    <a:ext uri="{05A4C25C-085E-4340-85A3-A5531E510DB2}">
+      <thm15:themeFamily xmlns:thm15="http://schemas.microsoft.com/office/thememl/2012/main" name="Office Theme" id="{2E142A2C-CD16-42D6-873A-C26D2A0506FA}" vid="{1BDDFF52-6CD6-40A5-AB3C-68EB2F1E4D0A}"/>
+    </a:ext>
+  </a:extLst>
+</a:theme>
 </file>
</xml_diff>